<commit_message>
Profile UI, home feed card, location editing, and service layout updates
- Frontend: LinkedIn-style profile and home sidebar (banner, avatar, headline,
  location, company hint), contact modal with city/state/country, nginx uploads
  routing, auth and media URL helpers.
- Profile service: banner on members, MemberUpdate banner field, /me location
  fields, upload URLs and schema helpers.
- Infrastructure and services: docker-compose and backend layout refactors,
  seed and analytics tweaks.

Excluded from commit: .env files, __pycache__/bytecode, and local upload assets.

Co-authored-by: Cursor <cursoragent@cursor.com>
</commit_message>
<xml_diff>
--- a/presentation/LinkedIn_Group6_Presentation.pptx
+++ b/presentation/LinkedIn_Group6_Presentation.pptx
@@ -5,20 +5,20 @@
     <p:sldMasterId id="2147483648" r:id="rId1"/>
   </p:sldMasterIdLst>
   <p:sldIdLst>
-    <p:sldId id="256" r:id="rId7"/>
-    <p:sldId id="257" r:id="rId8"/>
-    <p:sldId id="258" r:id="rId9"/>
-    <p:sldId id="259" r:id="rId10"/>
-    <p:sldId id="260" r:id="rId11"/>
-    <p:sldId id="261" r:id="rId12"/>
-    <p:sldId id="262" r:id="rId13"/>
-    <p:sldId id="263" r:id="rId14"/>
-    <p:sldId id="264" r:id="rId15"/>
-    <p:sldId id="265" r:id="rId16"/>
-    <p:sldId id="266" r:id="rId17"/>
-    <p:sldId id="267" r:id="rId18"/>
+    <p:sldId id="256" r:id="rId2"/>
+    <p:sldId id="257" r:id="rId3"/>
+    <p:sldId id="258" r:id="rId4"/>
+    <p:sldId id="259" r:id="rId5"/>
+    <p:sldId id="260" r:id="rId6"/>
+    <p:sldId id="261" r:id="rId7"/>
+    <p:sldId id="262" r:id="rId8"/>
+    <p:sldId id="263" r:id="rId9"/>
+    <p:sldId id="264" r:id="rId10"/>
+    <p:sldId id="265" r:id="rId11"/>
+    <p:sldId id="266" r:id="rId12"/>
+    <p:sldId id="267" r:id="rId13"/>
   </p:sldIdLst>
-  <p:sldSz cx="12188952" cy="6858000" type="screen4x3"/>
+  <p:sldSz cx="12188825" cy="6858000"/>
   <p:notesSz cx="6858000" cy="9144000"/>
   <p:defaultTextStyle>
     <a:defPPr>
@@ -115,12 +115,31 @@
       </a:defRPr>
     </a:lvl9pPr>
   </p:defaultTextStyle>
+  <p:extLst>
+    <p:ext uri="{EFAFB233-063F-42B5-8137-9DF3F51BA10A}">
+      <p15:sldGuideLst xmlns:p15="http://schemas.microsoft.com/office/powerpoint/2012/main">
+        <p15:guide id="1" orient="horz" pos="2160">
+          <p15:clr>
+            <a:srgbClr val="A4A3A4"/>
+          </p15:clr>
+        </p15:guide>
+        <p15:guide id="2" pos="2880">
+          <p15:clr>
+            <a:srgbClr val="A4A3A4"/>
+          </p15:clr>
+        </p15:guide>
+      </p15:sldGuideLst>
+    </p:ext>
+  </p:extLst>
 </p:presentation>
 </file>
 
 <file path=ppt/charts/chart1.xml><?xml version="1.0" encoding="utf-8"?>
-<c:chartSpace xmlns:c="http://schemas.openxmlformats.org/drawingml/2006/chart" xmlns:a="http://schemas.openxmlformats.org/drawingml/2006/main" xmlns:r="http://schemas.openxmlformats.org/officeDocument/2006/relationships">
+<c:chartSpace xmlns:c="http://schemas.openxmlformats.org/drawingml/2006/chart" xmlns:a="http://schemas.openxmlformats.org/drawingml/2006/main" xmlns:r="http://schemas.openxmlformats.org/officeDocument/2006/relationships" xmlns:c16r2="http://schemas.microsoft.com/office/drawing/2015/06/chart">
   <c:date1904 val="0"/>
+  <c:lang val="en-US"/>
+  <c:roundedCorners val="1"/>
+  <c:style val="2"/>
   <c:chart>
     <c:title>
       <c:tx>
@@ -136,19 +155,21 @@
               </a:defRPr>
             </a:pPr>
             <a:r>
+              <a:rPr lang="en-US"/>
               <a:t>Throughput (TPS) — with optimizations</a:t>
             </a:r>
           </a:p>
         </c:rich>
       </c:tx>
-      <c:layout/>
       <c:overlay val="0"/>
     </c:title>
     <c:autoTitleDeleted val="0"/>
     <c:plotArea>
+      <c:layout/>
       <c:barChart>
         <c:barDir val="col"/>
         <c:grouping val="clustered"/>
+        <c:varyColors val="1"/>
         <c:ser>
           <c:idx val="0"/>
           <c:order val="0"/>
@@ -163,30 +184,83 @@
               </c:strCache>
             </c:strRef>
           </c:tx>
+          <c:invertIfNegative val="1"/>
           <c:dPt>
             <c:idx val="0"/>
+            <c:invertIfNegative val="1"/>
+            <c:bubble3D val="0"/>
             <c:spPr>
               <a:solidFill>
                 <a:srgbClr val="057A55"/>
               </a:solidFill>
             </c:spPr>
+            <c:extLst>
+              <c:ext xmlns:c16="http://schemas.microsoft.com/office/drawing/2014/chart" uri="{C3380CC4-5D6E-409C-BE32-E72D297353CC}">
+                <c16:uniqueId val="{00000001-3A46-0D48-8080-7497A3C7BAED}"/>
+              </c:ext>
+            </c:extLst>
           </c:dPt>
           <c:dPt>
             <c:idx val="1"/>
+            <c:invertIfNegative val="1"/>
+            <c:bubble3D val="0"/>
             <c:spPr>
               <a:solidFill>
                 <a:srgbClr val="0A66C2"/>
               </a:solidFill>
             </c:spPr>
+            <c:extLst>
+              <c:ext xmlns:c16="http://schemas.microsoft.com/office/drawing/2014/chart" uri="{C3380CC4-5D6E-409C-BE32-E72D297353CC}">
+                <c16:uniqueId val="{00000003-3A46-0D48-8080-7497A3C7BAED}"/>
+              </c:ext>
+            </c:extLst>
           </c:dPt>
           <c:dPt>
             <c:idx val="2"/>
+            <c:invertIfNegative val="1"/>
+            <c:bubble3D val="0"/>
             <c:spPr>
               <a:solidFill>
                 <a:srgbClr val="E86A23"/>
               </a:solidFill>
             </c:spPr>
+            <c:extLst>
+              <c:ext xmlns:c16="http://schemas.microsoft.com/office/drawing/2014/chart" uri="{C3380CC4-5D6E-409C-BE32-E72D297353CC}">
+                <c16:uniqueId val="{00000005-3A46-0D48-8080-7497A3C7BAED}"/>
+              </c:ext>
+            </c:extLst>
           </c:dPt>
+          <c:dLbls>
+            <c:spPr>
+              <a:noFill/>
+              <a:ln>
+                <a:noFill/>
+              </a:ln>
+              <a:effectLst/>
+            </c:spPr>
+            <c:txPr>
+              <a:bodyPr/>
+              <a:lstStyle/>
+              <a:p>
+                <a:pPr>
+                  <a:defRPr sz="1100" b="1"/>
+                </a:pPr>
+                <a:endParaRPr lang="en-US"/>
+              </a:p>
+            </c:txPr>
+            <c:showLegendKey val="0"/>
+            <c:showVal val="1"/>
+            <c:showCatName val="0"/>
+            <c:showSerName val="0"/>
+            <c:showPercent val="0"/>
+            <c:showBubbleSize val="0"/>
+            <c:showLeaderLines val="0"/>
+            <c:extLst>
+              <c:ext xmlns:c15="http://schemas.microsoft.com/office/drawing/2012/chart" uri="{CE6537A1-D6FC-4f65-9D91-7224C49458BB}">
+                <c15:showLeaderLines val="0"/>
+              </c:ext>
+            </c:extLst>
+          </c:dLbls>
           <c:cat>
             <c:strRef>
               <c:f>Sheet1!$A$2:$A$4</c:f>
@@ -225,25 +299,21 @@
               </c:numCache>
             </c:numRef>
           </c:val>
+          <c:extLst>
+            <c:ext xmlns:c16="http://schemas.microsoft.com/office/drawing/2014/chart" uri="{C3380CC4-5D6E-409C-BE32-E72D297353CC}">
+              <c16:uniqueId val="{00000006-3A46-0D48-8080-7497A3C7BAED}"/>
+            </c:ext>
+          </c:extLst>
         </c:ser>
         <c:dLbls>
-          <c:txPr>
-            <a:bodyPr/>
-            <a:lstStyle/>
-            <a:p>
-              <a:pPr>
-                <a:defRPr sz="1100" b="1"/>
-              </a:pPr>
-            </a:p>
-          </c:txPr>
           <c:showLegendKey val="0"/>
           <c:showVal val="1"/>
           <c:showCatName val="0"/>
           <c:showSerName val="0"/>
           <c:showPercent val="0"/>
           <c:showBubbleSize val="0"/>
-          <c:showLeaderLines val="1"/>
         </c:dLbls>
+        <c:gapWidth val="150"/>
         <c:axId val="-2068027336"/>
         <c:axId val="-2113994440"/>
       </c:barChart>
@@ -254,6 +324,7 @@
         </c:scaling>
         <c:delete val="0"/>
         <c:axPos val="b"/>
+        <c:numFmt formatCode="General" sourceLinked="0"/>
         <c:majorTickMark val="out"/>
         <c:minorTickMark val="none"/>
         <c:tickLblPos val="nextTo"/>
@@ -266,18 +337,24 @@
       </c:catAx>
       <c:valAx>
         <c:axId val="-2113994440"/>
-        <c:scaling/>
+        <c:scaling>
+          <c:orientation val="minMax"/>
+        </c:scaling>
         <c:delete val="0"/>
         <c:axPos val="l"/>
         <c:majorGridlines/>
+        <c:numFmt formatCode="General" sourceLinked="1"/>
         <c:majorTickMark val="out"/>
         <c:minorTickMark val="none"/>
         <c:tickLblPos val="nextTo"/>
         <c:crossAx val="-2068027336"/>
         <c:crosses val="autoZero"/>
+        <c:crossBetween val="between"/>
       </c:valAx>
     </c:plotArea>
+    <c:plotVisOnly val="1"/>
     <c:dispBlanksAs val="gap"/>
+    <c:showDLblsOverMax val="1"/>
   </c:chart>
   <c:txPr>
     <a:bodyPr/>
@@ -296,8 +373,11 @@
 </file>
 
 <file path=ppt/charts/chart2.xml><?xml version="1.0" encoding="utf-8"?>
-<c:chartSpace xmlns:c="http://schemas.openxmlformats.org/drawingml/2006/chart" xmlns:a="http://schemas.openxmlformats.org/drawingml/2006/main" xmlns:r="http://schemas.openxmlformats.org/officeDocument/2006/relationships">
+<c:chartSpace xmlns:c="http://schemas.openxmlformats.org/drawingml/2006/chart" xmlns:a="http://schemas.openxmlformats.org/drawingml/2006/main" xmlns:r="http://schemas.openxmlformats.org/officeDocument/2006/relationships" xmlns:c16r2="http://schemas.microsoft.com/office/drawing/2015/06/chart">
   <c:date1904 val="0"/>
+  <c:lang val="en-US"/>
+  <c:roundedCorners val="1"/>
+  <c:style val="2"/>
   <c:chart>
     <c:title>
       <c:tx>
@@ -313,19 +393,21 @@
               </a:defRPr>
             </a:pPr>
             <a:r>
+              <a:rPr lang="en-US"/>
               <a:t>Avg Latency (ms) — with optimizations</a:t>
             </a:r>
           </a:p>
         </c:rich>
       </c:tx>
-      <c:layout/>
       <c:overlay val="0"/>
     </c:title>
     <c:autoTitleDeleted val="0"/>
     <c:plotArea>
+      <c:layout/>
       <c:barChart>
         <c:barDir val="col"/>
         <c:grouping val="clustered"/>
+        <c:varyColors val="1"/>
         <c:ser>
           <c:idx val="0"/>
           <c:order val="0"/>
@@ -340,30 +422,83 @@
               </c:strCache>
             </c:strRef>
           </c:tx>
+          <c:invertIfNegative val="1"/>
           <c:dPt>
             <c:idx val="0"/>
+            <c:invertIfNegative val="1"/>
+            <c:bubble3D val="0"/>
             <c:spPr>
               <a:solidFill>
                 <a:srgbClr val="057A55"/>
               </a:solidFill>
             </c:spPr>
+            <c:extLst>
+              <c:ext xmlns:c16="http://schemas.microsoft.com/office/drawing/2014/chart" uri="{C3380CC4-5D6E-409C-BE32-E72D297353CC}">
+                <c16:uniqueId val="{00000001-F7C6-2E4E-A2A8-720830FF8CA5}"/>
+              </c:ext>
+            </c:extLst>
           </c:dPt>
           <c:dPt>
             <c:idx val="1"/>
+            <c:invertIfNegative val="1"/>
+            <c:bubble3D val="0"/>
             <c:spPr>
               <a:solidFill>
                 <a:srgbClr val="0A66C2"/>
               </a:solidFill>
             </c:spPr>
+            <c:extLst>
+              <c:ext xmlns:c16="http://schemas.microsoft.com/office/drawing/2014/chart" uri="{C3380CC4-5D6E-409C-BE32-E72D297353CC}">
+                <c16:uniqueId val="{00000003-F7C6-2E4E-A2A8-720830FF8CA5}"/>
+              </c:ext>
+            </c:extLst>
           </c:dPt>
           <c:dPt>
             <c:idx val="2"/>
+            <c:invertIfNegative val="1"/>
+            <c:bubble3D val="0"/>
             <c:spPr>
               <a:solidFill>
                 <a:srgbClr val="E86A23"/>
               </a:solidFill>
             </c:spPr>
+            <c:extLst>
+              <c:ext xmlns:c16="http://schemas.microsoft.com/office/drawing/2014/chart" uri="{C3380CC4-5D6E-409C-BE32-E72D297353CC}">
+                <c16:uniqueId val="{00000005-F7C6-2E4E-A2A8-720830FF8CA5}"/>
+              </c:ext>
+            </c:extLst>
           </c:dPt>
+          <c:dLbls>
+            <c:spPr>
+              <a:noFill/>
+              <a:ln>
+                <a:noFill/>
+              </a:ln>
+              <a:effectLst/>
+            </c:spPr>
+            <c:txPr>
+              <a:bodyPr/>
+              <a:lstStyle/>
+              <a:p>
+                <a:pPr>
+                  <a:defRPr sz="1100" b="1"/>
+                </a:pPr>
+                <a:endParaRPr lang="en-US"/>
+              </a:p>
+            </c:txPr>
+            <c:showLegendKey val="0"/>
+            <c:showVal val="1"/>
+            <c:showCatName val="0"/>
+            <c:showSerName val="0"/>
+            <c:showPercent val="0"/>
+            <c:showBubbleSize val="0"/>
+            <c:showLeaderLines val="0"/>
+            <c:extLst>
+              <c:ext xmlns:c15="http://schemas.microsoft.com/office/drawing/2012/chart" uri="{CE6537A1-D6FC-4f65-9D91-7224C49458BB}">
+                <c15:showLeaderLines val="0"/>
+              </c:ext>
+            </c:extLst>
+          </c:dLbls>
           <c:cat>
             <c:strRef>
               <c:f>Sheet1!$A$2:$A$4</c:f>
@@ -402,25 +537,21 @@
               </c:numCache>
             </c:numRef>
           </c:val>
+          <c:extLst>
+            <c:ext xmlns:c16="http://schemas.microsoft.com/office/drawing/2014/chart" uri="{C3380CC4-5D6E-409C-BE32-E72D297353CC}">
+              <c16:uniqueId val="{00000006-F7C6-2E4E-A2A8-720830FF8CA5}"/>
+            </c:ext>
+          </c:extLst>
         </c:ser>
         <c:dLbls>
-          <c:txPr>
-            <a:bodyPr/>
-            <a:lstStyle/>
-            <a:p>
-              <a:pPr>
-                <a:defRPr sz="1100" b="1"/>
-              </a:pPr>
-            </a:p>
-          </c:txPr>
           <c:showLegendKey val="0"/>
           <c:showVal val="1"/>
           <c:showCatName val="0"/>
           <c:showSerName val="0"/>
           <c:showPercent val="0"/>
           <c:showBubbleSize val="0"/>
-          <c:showLeaderLines val="1"/>
         </c:dLbls>
+        <c:gapWidth val="150"/>
         <c:axId val="-2068027336"/>
         <c:axId val="-2113994440"/>
       </c:barChart>
@@ -431,6 +562,7 @@
         </c:scaling>
         <c:delete val="0"/>
         <c:axPos val="b"/>
+        <c:numFmt formatCode="General" sourceLinked="0"/>
         <c:majorTickMark val="out"/>
         <c:minorTickMark val="none"/>
         <c:tickLblPos val="nextTo"/>
@@ -443,18 +575,24 @@
       </c:catAx>
       <c:valAx>
         <c:axId val="-2113994440"/>
-        <c:scaling/>
+        <c:scaling>
+          <c:orientation val="minMax"/>
+        </c:scaling>
         <c:delete val="0"/>
         <c:axPos val="l"/>
         <c:majorGridlines/>
+        <c:numFmt formatCode="General" sourceLinked="1"/>
         <c:majorTickMark val="out"/>
         <c:minorTickMark val="none"/>
         <c:tickLblPos val="nextTo"/>
         <c:crossAx val="-2068027336"/>
         <c:crosses val="autoZero"/>
+        <c:crossBetween val="between"/>
       </c:valAx>
     </c:plotArea>
+    <c:plotVisOnly val="1"/>
     <c:dispBlanksAs val="gap"/>
+    <c:showDLblsOverMax val="1"/>
   </c:chart>
   <c:txPr>
     <a:bodyPr/>
@@ -473,8 +611,11 @@
 </file>
 
 <file path=ppt/charts/chart3.xml><?xml version="1.0" encoding="utf-8"?>
-<c:chartSpace xmlns:c="http://schemas.openxmlformats.org/drawingml/2006/chart" xmlns:a="http://schemas.openxmlformats.org/drawingml/2006/main" xmlns:r="http://schemas.openxmlformats.org/officeDocument/2006/relationships">
+<c:chartSpace xmlns:c="http://schemas.openxmlformats.org/drawingml/2006/chart" xmlns:a="http://schemas.openxmlformats.org/drawingml/2006/main" xmlns:r="http://schemas.openxmlformats.org/officeDocument/2006/relationships" xmlns:c16r2="http://schemas.microsoft.com/office/drawing/2015/06/chart">
   <c:date1904 val="0"/>
+  <c:lang val="en-US"/>
+  <c:roundedCorners val="1"/>
+  <c:style val="2"/>
   <c:chart>
     <c:title>
       <c:tx>
@@ -490,16 +631,17 @@
               </a:defRPr>
             </a:pPr>
             <a:r>
+              <a:rPr lang="en-US"/>
               <a:t>Throughput (TPS) vs Concurrency ↑</a:t>
             </a:r>
           </a:p>
         </c:rich>
       </c:tx>
-      <c:layout/>
       <c:overlay val="0"/>
     </c:title>
     <c:autoTitleDeleted val="0"/>
     <c:plotArea>
+      <c:layout/>
       <c:lineChart>
         <c:grouping val="standard"/>
         <c:varyColors val="0"/>
@@ -520,6 +662,37 @@
           <c:marker>
             <c:symbol val="none"/>
           </c:marker>
+          <c:dLbls>
+            <c:spPr>
+              <a:noFill/>
+              <a:ln>
+                <a:noFill/>
+              </a:ln>
+              <a:effectLst/>
+            </c:spPr>
+            <c:txPr>
+              <a:bodyPr/>
+              <a:lstStyle/>
+              <a:p>
+                <a:pPr>
+                  <a:defRPr sz="1000" b="1"/>
+                </a:pPr>
+                <a:endParaRPr lang="en-US"/>
+              </a:p>
+            </c:txPr>
+            <c:showLegendKey val="0"/>
+            <c:showVal val="1"/>
+            <c:showCatName val="0"/>
+            <c:showSerName val="0"/>
+            <c:showPercent val="0"/>
+            <c:showBubbleSize val="0"/>
+            <c:showLeaderLines val="0"/>
+            <c:extLst>
+              <c:ext xmlns:c15="http://schemas.microsoft.com/office/drawing/2012/chart" uri="{CE6537A1-D6FC-4f65-9D91-7224C49458BB}">
+                <c15:showLeaderLines val="0"/>
+              </c:ext>
+            </c:extLst>
+          </c:dLbls>
           <c:cat>
             <c:strRef>
               <c:f>Sheet1!$A$2:$A$5</c:f>
@@ -562,26 +735,20 @@
             </c:numRef>
           </c:val>
           <c:smooth val="0"/>
+          <c:extLst>
+            <c:ext xmlns:c16="http://schemas.microsoft.com/office/drawing/2014/chart" uri="{C3380CC4-5D6E-409C-BE32-E72D297353CC}">
+              <c16:uniqueId val="{00000000-E75D-0047-BD43-D0A751DEFE4F}"/>
+            </c:ext>
+          </c:extLst>
         </c:ser>
         <c:dLbls>
-          <c:txPr>
-            <a:bodyPr/>
-            <a:lstStyle/>
-            <a:p>
-              <a:pPr>
-                <a:defRPr sz="1000" b="1"/>
-              </a:pPr>
-            </a:p>
-          </c:txPr>
           <c:showLegendKey val="0"/>
           <c:showVal val="1"/>
           <c:showCatName val="0"/>
           <c:showSerName val="0"/>
           <c:showPercent val="0"/>
           <c:showBubbleSize val="0"/>
-          <c:showLeaderLines val="1"/>
         </c:dLbls>
-        <c:marker val="1"/>
         <c:smooth val="0"/>
         <c:axId val="2118791784"/>
         <c:axId val="2140495176"/>
@@ -593,6 +760,7 @@
         </c:scaling>
         <c:delete val="0"/>
         <c:axPos val="b"/>
+        <c:numFmt formatCode="General" sourceLinked="0"/>
         <c:majorTickMark val="out"/>
         <c:minorTickMark val="none"/>
         <c:tickLblPos val="nextTo"/>
@@ -605,20 +773,23 @@
       </c:catAx>
       <c:valAx>
         <c:axId val="2140495176"/>
-        <c:scaling/>
+        <c:scaling>
+          <c:orientation val="minMax"/>
+        </c:scaling>
         <c:delete val="0"/>
         <c:axPos val="l"/>
         <c:majorGridlines/>
+        <c:numFmt formatCode="General" sourceLinked="1"/>
         <c:majorTickMark val="out"/>
         <c:minorTickMark val="none"/>
         <c:tickLblPos val="nextTo"/>
         <c:crossAx val="2118791784"/>
         <c:crosses val="autoZero"/>
+        <c:crossBetween val="between"/>
       </c:valAx>
     </c:plotArea>
     <c:legend>
       <c:legendPos val="r"/>
-      <c:layout/>
       <c:overlay val="0"/>
     </c:legend>
     <c:plotVisOnly val="1"/>
@@ -642,8 +813,11 @@
 </file>
 
 <file path=ppt/charts/chart4.xml><?xml version="1.0" encoding="utf-8"?>
-<c:chartSpace xmlns:c="http://schemas.openxmlformats.org/drawingml/2006/chart" xmlns:a="http://schemas.openxmlformats.org/drawingml/2006/main" xmlns:r="http://schemas.openxmlformats.org/officeDocument/2006/relationships">
+<c:chartSpace xmlns:c="http://schemas.openxmlformats.org/drawingml/2006/chart" xmlns:a="http://schemas.openxmlformats.org/drawingml/2006/main" xmlns:r="http://schemas.openxmlformats.org/officeDocument/2006/relationships" xmlns:c16r2="http://schemas.microsoft.com/office/drawing/2015/06/chart">
   <c:date1904 val="0"/>
+  <c:lang val="en-US"/>
+  <c:roundedCorners val="1"/>
+  <c:style val="2"/>
   <c:chart>
     <c:title>
       <c:tx>
@@ -659,19 +833,21 @@
               </a:defRPr>
             </a:pPr>
             <a:r>
+              <a:rPr lang="en-US"/>
               <a:t>P90 vs P99 Latency (ms) — optimized</a:t>
             </a:r>
           </a:p>
         </c:rich>
       </c:tx>
-      <c:layout/>
       <c:overlay val="0"/>
     </c:title>
     <c:autoTitleDeleted val="0"/>
     <c:plotArea>
+      <c:layout/>
       <c:barChart>
         <c:barDir val="col"/>
         <c:grouping val="clustered"/>
+        <c:varyColors val="1"/>
         <c:ser>
           <c:idx val="0"/>
           <c:order val="0"/>
@@ -691,6 +867,38 @@
               <a:srgbClr val="0A66C2"/>
             </a:solidFill>
           </c:spPr>
+          <c:invertIfNegative val="1"/>
+          <c:dLbls>
+            <c:spPr>
+              <a:noFill/>
+              <a:ln>
+                <a:noFill/>
+              </a:ln>
+              <a:effectLst/>
+            </c:spPr>
+            <c:txPr>
+              <a:bodyPr/>
+              <a:lstStyle/>
+              <a:p>
+                <a:pPr>
+                  <a:defRPr sz="1000" b="1"/>
+                </a:pPr>
+                <a:endParaRPr lang="en-US"/>
+              </a:p>
+            </c:txPr>
+            <c:showLegendKey val="0"/>
+            <c:showVal val="1"/>
+            <c:showCatName val="0"/>
+            <c:showSerName val="0"/>
+            <c:showPercent val="0"/>
+            <c:showBubbleSize val="0"/>
+            <c:showLeaderLines val="0"/>
+            <c:extLst>
+              <c:ext xmlns:c15="http://schemas.microsoft.com/office/drawing/2012/chart" uri="{CE6537A1-D6FC-4f65-9D91-7224C49458BB}">
+                <c15:showLeaderLines val="0"/>
+              </c:ext>
+            </c:extLst>
+          </c:dLbls>
           <c:cat>
             <c:strRef>
               <c:f>Sheet1!$A$2:$A$4</c:f>
@@ -729,6 +937,20 @@
               </c:numCache>
             </c:numRef>
           </c:val>
+          <c:extLst>
+            <c:ext xmlns:c14="http://schemas.microsoft.com/office/drawing/2007/8/2/chart" uri="{6F2FDCE9-48DA-4B69-8628-5D25D57E5C99}">
+              <c14:invertSolidFillFmt>
+                <c14:spPr xmlns:c14="http://schemas.microsoft.com/office/drawing/2007/8/2/chart">
+                  <a:solidFill>
+                    <a:srgbClr val="FFFFFF"/>
+                  </a:solidFill>
+                </c14:spPr>
+              </c14:invertSolidFillFmt>
+            </c:ext>
+            <c:ext xmlns:c16="http://schemas.microsoft.com/office/drawing/2014/chart" uri="{C3380CC4-5D6E-409C-BE32-E72D297353CC}">
+              <c16:uniqueId val="{00000000-1F7E-5C4F-AECD-18CCAEAEFF89}"/>
+            </c:ext>
+          </c:extLst>
         </c:ser>
         <c:ser>
           <c:idx val="1"/>
@@ -749,6 +971,38 @@
               <a:srgbClr val="E86A23"/>
             </a:solidFill>
           </c:spPr>
+          <c:invertIfNegative val="1"/>
+          <c:dLbls>
+            <c:spPr>
+              <a:noFill/>
+              <a:ln>
+                <a:noFill/>
+              </a:ln>
+              <a:effectLst/>
+            </c:spPr>
+            <c:txPr>
+              <a:bodyPr/>
+              <a:lstStyle/>
+              <a:p>
+                <a:pPr>
+                  <a:defRPr sz="1000" b="1"/>
+                </a:pPr>
+                <a:endParaRPr lang="en-US"/>
+              </a:p>
+            </c:txPr>
+            <c:showLegendKey val="0"/>
+            <c:showVal val="1"/>
+            <c:showCatName val="0"/>
+            <c:showSerName val="0"/>
+            <c:showPercent val="0"/>
+            <c:showBubbleSize val="0"/>
+            <c:showLeaderLines val="0"/>
+            <c:extLst>
+              <c:ext xmlns:c15="http://schemas.microsoft.com/office/drawing/2012/chart" uri="{CE6537A1-D6FC-4f65-9D91-7224C49458BB}">
+                <c15:showLeaderLines val="0"/>
+              </c:ext>
+            </c:extLst>
+          </c:dLbls>
           <c:cat>
             <c:strRef>
               <c:f>Sheet1!$A$2:$A$4</c:f>
@@ -787,25 +1041,30 @@
               </c:numCache>
             </c:numRef>
           </c:val>
+          <c:extLst>
+            <c:ext xmlns:c14="http://schemas.microsoft.com/office/drawing/2007/8/2/chart" uri="{6F2FDCE9-48DA-4B69-8628-5D25D57E5C99}">
+              <c14:invertSolidFillFmt>
+                <c14:spPr xmlns:c14="http://schemas.microsoft.com/office/drawing/2007/8/2/chart">
+                  <a:solidFill>
+                    <a:srgbClr val="FFFFFF"/>
+                  </a:solidFill>
+                </c14:spPr>
+              </c14:invertSolidFillFmt>
+            </c:ext>
+            <c:ext xmlns:c16="http://schemas.microsoft.com/office/drawing/2014/chart" uri="{C3380CC4-5D6E-409C-BE32-E72D297353CC}">
+              <c16:uniqueId val="{00000001-1F7E-5C4F-AECD-18CCAEAEFF89}"/>
+            </c:ext>
+          </c:extLst>
         </c:ser>
         <c:dLbls>
-          <c:txPr>
-            <a:bodyPr/>
-            <a:lstStyle/>
-            <a:p>
-              <a:pPr>
-                <a:defRPr sz="1000" b="1"/>
-              </a:pPr>
-            </a:p>
-          </c:txPr>
           <c:showLegendKey val="0"/>
           <c:showVal val="1"/>
           <c:showCatName val="0"/>
           <c:showSerName val="0"/>
           <c:showPercent val="0"/>
           <c:showBubbleSize val="0"/>
-          <c:showLeaderLines val="1"/>
         </c:dLbls>
+        <c:gapWidth val="150"/>
         <c:axId val="-2068027336"/>
         <c:axId val="-2113994440"/>
       </c:barChart>
@@ -816,6 +1075,7 @@
         </c:scaling>
         <c:delete val="0"/>
         <c:axPos val="b"/>
+        <c:numFmt formatCode="General" sourceLinked="0"/>
         <c:majorTickMark val="out"/>
         <c:minorTickMark val="none"/>
         <c:tickLblPos val="nextTo"/>
@@ -828,18 +1088,24 @@
       </c:catAx>
       <c:valAx>
         <c:axId val="-2113994440"/>
-        <c:scaling/>
+        <c:scaling>
+          <c:orientation val="minMax"/>
+        </c:scaling>
         <c:delete val="0"/>
         <c:axPos val="l"/>
         <c:majorGridlines/>
+        <c:numFmt formatCode="General" sourceLinked="1"/>
         <c:majorTickMark val="out"/>
         <c:minorTickMark val="none"/>
         <c:tickLblPos val="nextTo"/>
         <c:crossAx val="-2068027336"/>
         <c:crosses val="autoZero"/>
+        <c:crossBetween val="between"/>
       </c:valAx>
     </c:plotArea>
+    <c:plotVisOnly val="1"/>
     <c:dispBlanksAs val="gap"/>
+    <c:showDLblsOverMax val="1"/>
   </c:chart>
   <c:txPr>
     <a:bodyPr/>
@@ -895,10 +1161,9 @@
           <a:lstStyle/>
           <a:p>
             <a:r>
-              <a:rPr lang="en-US" smtClean="0"/>
+              <a:rPr lang="en-US"/>
               <a:t>Click to edit Master title style</a:t>
             </a:r>
-            <a:endParaRPr lang="en-US"/>
           </a:p>
         </p:txBody>
       </p:sp>
@@ -1014,10 +1279,9 @@
           </a:lstStyle>
           <a:p>
             <a:r>
-              <a:rPr lang="en-US" smtClean="0"/>
+              <a:rPr lang="en-US"/>
               <a:t>Click to edit Master subtitle style</a:t>
             </a:r>
-            <a:endParaRPr lang="en-US"/>
           </a:p>
         </p:txBody>
       </p:sp>
@@ -1038,7 +1302,7 @@
           <a:p>
             <a:fld id="{5BCAD085-E8A6-8845-BD4E-CB4CCA059FC4}" type="datetimeFigureOut">
               <a:rPr lang="en-US" smtClean="0"/>
-              <a:t>1/27/13</a:t>
+              <a:t>4/27/26</a:t>
             </a:fld>
             <a:endParaRPr lang="en-US"/>
           </a:p>
@@ -1132,10 +1396,9 @@
           <a:lstStyle/>
           <a:p>
             <a:r>
-              <a:rPr lang="en-US" smtClean="0"/>
+              <a:rPr lang="en-US"/>
               <a:t>Click to edit Master title style</a:t>
             </a:r>
-            <a:endParaRPr lang="en-US"/>
           </a:p>
         </p:txBody>
       </p:sp>
@@ -1156,38 +1419,37 @@
           <a:p>
             <a:pPr lvl="0"/>
             <a:r>
-              <a:rPr lang="en-US" smtClean="0"/>
+              <a:rPr lang="en-US"/>
               <a:t>Click to edit Master text styles</a:t>
             </a:r>
           </a:p>
           <a:p>
             <a:pPr lvl="1"/>
             <a:r>
-              <a:rPr lang="en-US" smtClean="0"/>
+              <a:rPr lang="en-US"/>
               <a:t>Second level</a:t>
             </a:r>
           </a:p>
           <a:p>
             <a:pPr lvl="2"/>
             <a:r>
-              <a:rPr lang="en-US" smtClean="0"/>
+              <a:rPr lang="en-US"/>
               <a:t>Third level</a:t>
             </a:r>
           </a:p>
           <a:p>
             <a:pPr lvl="3"/>
             <a:r>
-              <a:rPr lang="en-US" smtClean="0"/>
+              <a:rPr lang="en-US"/>
               <a:t>Fourth level</a:t>
             </a:r>
           </a:p>
           <a:p>
             <a:pPr lvl="4"/>
             <a:r>
-              <a:rPr lang="en-US" smtClean="0"/>
+              <a:rPr lang="en-US"/>
               <a:t>Fifth level</a:t>
             </a:r>
-            <a:endParaRPr lang="en-US"/>
           </a:p>
         </p:txBody>
       </p:sp>
@@ -1208,7 +1470,7 @@
           <a:p>
             <a:fld id="{5BCAD085-E8A6-8845-BD4E-CB4CCA059FC4}" type="datetimeFigureOut">
               <a:rPr lang="en-US" smtClean="0"/>
-              <a:t>1/27/13</a:t>
+              <a:t>4/27/26</a:t>
             </a:fld>
             <a:endParaRPr lang="en-US"/>
           </a:p>
@@ -1307,10 +1569,9 @@
           <a:lstStyle/>
           <a:p>
             <a:r>
-              <a:rPr lang="en-US" smtClean="0"/>
+              <a:rPr lang="en-US"/>
               <a:t>Click to edit Master title style</a:t>
             </a:r>
-            <a:endParaRPr lang="en-US"/>
           </a:p>
         </p:txBody>
       </p:sp>
@@ -1336,38 +1597,37 @@
           <a:p>
             <a:pPr lvl="0"/>
             <a:r>
-              <a:rPr lang="en-US" smtClean="0"/>
+              <a:rPr lang="en-US"/>
               <a:t>Click to edit Master text styles</a:t>
             </a:r>
           </a:p>
           <a:p>
             <a:pPr lvl="1"/>
             <a:r>
-              <a:rPr lang="en-US" smtClean="0"/>
+              <a:rPr lang="en-US"/>
               <a:t>Second level</a:t>
             </a:r>
           </a:p>
           <a:p>
             <a:pPr lvl="2"/>
             <a:r>
-              <a:rPr lang="en-US" smtClean="0"/>
+              <a:rPr lang="en-US"/>
               <a:t>Third level</a:t>
             </a:r>
           </a:p>
           <a:p>
             <a:pPr lvl="3"/>
             <a:r>
-              <a:rPr lang="en-US" smtClean="0"/>
+              <a:rPr lang="en-US"/>
               <a:t>Fourth level</a:t>
             </a:r>
           </a:p>
           <a:p>
             <a:pPr lvl="4"/>
             <a:r>
-              <a:rPr lang="en-US" smtClean="0"/>
+              <a:rPr lang="en-US"/>
               <a:t>Fifth level</a:t>
             </a:r>
-            <a:endParaRPr lang="en-US"/>
           </a:p>
         </p:txBody>
       </p:sp>
@@ -1388,7 +1648,7 @@
           <a:p>
             <a:fld id="{5BCAD085-E8A6-8845-BD4E-CB4CCA059FC4}" type="datetimeFigureOut">
               <a:rPr lang="en-US" smtClean="0"/>
-              <a:t>1/27/13</a:t>
+              <a:t>4/27/26</a:t>
             </a:fld>
             <a:endParaRPr lang="en-US"/>
           </a:p>
@@ -1482,10 +1742,9 @@
           <a:lstStyle/>
           <a:p>
             <a:r>
-              <a:rPr lang="en-US" smtClean="0"/>
+              <a:rPr lang="en-US"/>
               <a:t>Click to edit Master title style</a:t>
             </a:r>
-            <a:endParaRPr lang="en-US"/>
           </a:p>
         </p:txBody>
       </p:sp>
@@ -1506,38 +1765,37 @@
           <a:p>
             <a:pPr lvl="0"/>
             <a:r>
-              <a:rPr lang="en-US" smtClean="0"/>
+              <a:rPr lang="en-US"/>
               <a:t>Click to edit Master text styles</a:t>
             </a:r>
           </a:p>
           <a:p>
             <a:pPr lvl="1"/>
             <a:r>
-              <a:rPr lang="en-US" smtClean="0"/>
+              <a:rPr lang="en-US"/>
               <a:t>Second level</a:t>
             </a:r>
           </a:p>
           <a:p>
             <a:pPr lvl="2"/>
             <a:r>
-              <a:rPr lang="en-US" smtClean="0"/>
+              <a:rPr lang="en-US"/>
               <a:t>Third level</a:t>
             </a:r>
           </a:p>
           <a:p>
             <a:pPr lvl="3"/>
             <a:r>
-              <a:rPr lang="en-US" smtClean="0"/>
+              <a:rPr lang="en-US"/>
               <a:t>Fourth level</a:t>
             </a:r>
           </a:p>
           <a:p>
             <a:pPr lvl="4"/>
             <a:r>
-              <a:rPr lang="en-US" smtClean="0"/>
+              <a:rPr lang="en-US"/>
               <a:t>Fifth level</a:t>
             </a:r>
-            <a:endParaRPr lang="en-US"/>
           </a:p>
         </p:txBody>
       </p:sp>
@@ -1558,7 +1816,7 @@
           <a:p>
             <a:fld id="{5BCAD085-E8A6-8845-BD4E-CB4CCA059FC4}" type="datetimeFigureOut">
               <a:rPr lang="en-US" smtClean="0"/>
-              <a:t>1/27/13</a:t>
+              <a:t>4/27/26</a:t>
             </a:fld>
             <a:endParaRPr lang="en-US"/>
           </a:p>
@@ -1661,10 +1919,9 @@
           </a:lstStyle>
           <a:p>
             <a:r>
-              <a:rPr lang="en-US" smtClean="0"/>
+              <a:rPr lang="en-US"/>
               <a:t>Click to edit Master title style</a:t>
             </a:r>
-            <a:endParaRPr lang="en-US"/>
           </a:p>
         </p:txBody>
       </p:sp>
@@ -1781,7 +2038,7 @@
           <a:p>
             <a:pPr lvl="0"/>
             <a:r>
-              <a:rPr lang="en-US" smtClean="0"/>
+              <a:rPr lang="en-US"/>
               <a:t>Click to edit Master text styles</a:t>
             </a:r>
           </a:p>
@@ -1804,7 +2061,7 @@
           <a:p>
             <a:fld id="{5BCAD085-E8A6-8845-BD4E-CB4CCA059FC4}" type="datetimeFigureOut">
               <a:rPr lang="en-US" smtClean="0"/>
-              <a:t>1/27/13</a:t>
+              <a:t>4/27/26</a:t>
             </a:fld>
             <a:endParaRPr lang="en-US"/>
           </a:p>
@@ -1898,10 +2155,9 @@
           <a:lstStyle/>
           <a:p>
             <a:r>
-              <a:rPr lang="en-US" smtClean="0"/>
+              <a:rPr lang="en-US"/>
               <a:t>Click to edit Master title style</a:t>
             </a:r>
-            <a:endParaRPr lang="en-US"/>
           </a:p>
         </p:txBody>
       </p:sp>
@@ -1955,38 +2211,37 @@
           <a:p>
             <a:pPr lvl="0"/>
             <a:r>
-              <a:rPr lang="en-US" smtClean="0"/>
+              <a:rPr lang="en-US"/>
               <a:t>Click to edit Master text styles</a:t>
             </a:r>
           </a:p>
           <a:p>
             <a:pPr lvl="1"/>
             <a:r>
-              <a:rPr lang="en-US" smtClean="0"/>
+              <a:rPr lang="en-US"/>
               <a:t>Second level</a:t>
             </a:r>
           </a:p>
           <a:p>
             <a:pPr lvl="2"/>
             <a:r>
-              <a:rPr lang="en-US" smtClean="0"/>
+              <a:rPr lang="en-US"/>
               <a:t>Third level</a:t>
             </a:r>
           </a:p>
           <a:p>
             <a:pPr lvl="3"/>
             <a:r>
-              <a:rPr lang="en-US" smtClean="0"/>
+              <a:rPr lang="en-US"/>
               <a:t>Fourth level</a:t>
             </a:r>
           </a:p>
           <a:p>
             <a:pPr lvl="4"/>
             <a:r>
-              <a:rPr lang="en-US" smtClean="0"/>
+              <a:rPr lang="en-US"/>
               <a:t>Fifth level</a:t>
             </a:r>
-            <a:endParaRPr lang="en-US"/>
           </a:p>
         </p:txBody>
       </p:sp>
@@ -2040,38 +2295,37 @@
           <a:p>
             <a:pPr lvl="0"/>
             <a:r>
-              <a:rPr lang="en-US" smtClean="0"/>
+              <a:rPr lang="en-US"/>
               <a:t>Click to edit Master text styles</a:t>
             </a:r>
           </a:p>
           <a:p>
             <a:pPr lvl="1"/>
             <a:r>
-              <a:rPr lang="en-US" smtClean="0"/>
+              <a:rPr lang="en-US"/>
               <a:t>Second level</a:t>
             </a:r>
           </a:p>
           <a:p>
             <a:pPr lvl="2"/>
             <a:r>
-              <a:rPr lang="en-US" smtClean="0"/>
+              <a:rPr lang="en-US"/>
               <a:t>Third level</a:t>
             </a:r>
           </a:p>
           <a:p>
             <a:pPr lvl="3"/>
             <a:r>
-              <a:rPr lang="en-US" smtClean="0"/>
+              <a:rPr lang="en-US"/>
               <a:t>Fourth level</a:t>
             </a:r>
           </a:p>
           <a:p>
             <a:pPr lvl="4"/>
             <a:r>
-              <a:rPr lang="en-US" smtClean="0"/>
+              <a:rPr lang="en-US"/>
               <a:t>Fifth level</a:t>
             </a:r>
-            <a:endParaRPr lang="en-US"/>
           </a:p>
         </p:txBody>
       </p:sp>
@@ -2092,7 +2346,7 @@
           <a:p>
             <a:fld id="{5BCAD085-E8A6-8845-BD4E-CB4CCA059FC4}" type="datetimeFigureOut">
               <a:rPr lang="en-US" smtClean="0"/>
-              <a:t>1/27/13</a:t>
+              <a:t>4/27/26</a:t>
             </a:fld>
             <a:endParaRPr lang="en-US"/>
           </a:p>
@@ -2190,10 +2444,9 @@
           </a:lstStyle>
           <a:p>
             <a:r>
-              <a:rPr lang="en-US" smtClean="0"/>
+              <a:rPr lang="en-US"/>
               <a:t>Click to edit Master title style</a:t>
             </a:r>
-            <a:endParaRPr lang="en-US"/>
           </a:p>
         </p:txBody>
       </p:sp>
@@ -2256,7 +2509,7 @@
           <a:p>
             <a:pPr lvl="0"/>
             <a:r>
-              <a:rPr lang="en-US" smtClean="0"/>
+              <a:rPr lang="en-US"/>
               <a:t>Click to edit Master text styles</a:t>
             </a:r>
           </a:p>
@@ -2312,38 +2565,37 @@
           <a:p>
             <a:pPr lvl="0"/>
             <a:r>
-              <a:rPr lang="en-US" smtClean="0"/>
+              <a:rPr lang="en-US"/>
               <a:t>Click to edit Master text styles</a:t>
             </a:r>
           </a:p>
           <a:p>
             <a:pPr lvl="1"/>
             <a:r>
-              <a:rPr lang="en-US" smtClean="0"/>
+              <a:rPr lang="en-US"/>
               <a:t>Second level</a:t>
             </a:r>
           </a:p>
           <a:p>
             <a:pPr lvl="2"/>
             <a:r>
-              <a:rPr lang="en-US" smtClean="0"/>
+              <a:rPr lang="en-US"/>
               <a:t>Third level</a:t>
             </a:r>
           </a:p>
           <a:p>
             <a:pPr lvl="3"/>
             <a:r>
-              <a:rPr lang="en-US" smtClean="0"/>
+              <a:rPr lang="en-US"/>
               <a:t>Fourth level</a:t>
             </a:r>
           </a:p>
           <a:p>
             <a:pPr lvl="4"/>
             <a:r>
-              <a:rPr lang="en-US" smtClean="0"/>
+              <a:rPr lang="en-US"/>
               <a:t>Fifth level</a:t>
             </a:r>
-            <a:endParaRPr lang="en-US"/>
           </a:p>
         </p:txBody>
       </p:sp>
@@ -2406,7 +2658,7 @@
           <a:p>
             <a:pPr lvl="0"/>
             <a:r>
-              <a:rPr lang="en-US" smtClean="0"/>
+              <a:rPr lang="en-US"/>
               <a:t>Click to edit Master text styles</a:t>
             </a:r>
           </a:p>
@@ -2462,38 +2714,37 @@
           <a:p>
             <a:pPr lvl="0"/>
             <a:r>
-              <a:rPr lang="en-US" smtClean="0"/>
+              <a:rPr lang="en-US"/>
               <a:t>Click to edit Master text styles</a:t>
             </a:r>
           </a:p>
           <a:p>
             <a:pPr lvl="1"/>
             <a:r>
-              <a:rPr lang="en-US" smtClean="0"/>
+              <a:rPr lang="en-US"/>
               <a:t>Second level</a:t>
             </a:r>
           </a:p>
           <a:p>
             <a:pPr lvl="2"/>
             <a:r>
-              <a:rPr lang="en-US" smtClean="0"/>
+              <a:rPr lang="en-US"/>
               <a:t>Third level</a:t>
             </a:r>
           </a:p>
           <a:p>
             <a:pPr lvl="3"/>
             <a:r>
-              <a:rPr lang="en-US" smtClean="0"/>
+              <a:rPr lang="en-US"/>
               <a:t>Fourth level</a:t>
             </a:r>
           </a:p>
           <a:p>
             <a:pPr lvl="4"/>
             <a:r>
-              <a:rPr lang="en-US" smtClean="0"/>
+              <a:rPr lang="en-US"/>
               <a:t>Fifth level</a:t>
             </a:r>
-            <a:endParaRPr lang="en-US"/>
           </a:p>
         </p:txBody>
       </p:sp>
@@ -2514,7 +2765,7 @@
           <a:p>
             <a:fld id="{5BCAD085-E8A6-8845-BD4E-CB4CCA059FC4}" type="datetimeFigureOut">
               <a:rPr lang="en-US" smtClean="0"/>
-              <a:t>1/27/13</a:t>
+              <a:t>4/27/26</a:t>
             </a:fld>
             <a:endParaRPr lang="en-US"/>
           </a:p>
@@ -2608,10 +2859,9 @@
           <a:lstStyle/>
           <a:p>
             <a:r>
-              <a:rPr lang="en-US" smtClean="0"/>
+              <a:rPr lang="en-US"/>
               <a:t>Click to edit Master title style</a:t>
             </a:r>
-            <a:endParaRPr lang="en-US"/>
           </a:p>
         </p:txBody>
       </p:sp>
@@ -2632,7 +2882,7 @@
           <a:p>
             <a:fld id="{5BCAD085-E8A6-8845-BD4E-CB4CCA059FC4}" type="datetimeFigureOut">
               <a:rPr lang="en-US" smtClean="0"/>
-              <a:t>1/27/13</a:t>
+              <a:t>4/27/26</a:t>
             </a:fld>
             <a:endParaRPr lang="en-US"/>
           </a:p>
@@ -2727,7 +2977,7 @@
           <a:p>
             <a:fld id="{5BCAD085-E8A6-8845-BD4E-CB4CCA059FC4}" type="datetimeFigureOut">
               <a:rPr lang="en-US" smtClean="0"/>
-              <a:t>1/27/13</a:t>
+              <a:t>4/27/26</a:t>
             </a:fld>
             <a:endParaRPr lang="en-US"/>
           </a:p>
@@ -2830,10 +3080,9 @@
           </a:lstStyle>
           <a:p>
             <a:r>
-              <a:rPr lang="en-US" smtClean="0"/>
+              <a:rPr lang="en-US"/>
               <a:t>Click to edit Master title style</a:t>
             </a:r>
-            <a:endParaRPr lang="en-US"/>
           </a:p>
         </p:txBody>
       </p:sp>
@@ -2887,38 +3136,37 @@
           <a:p>
             <a:pPr lvl="0"/>
             <a:r>
-              <a:rPr lang="en-US" smtClean="0"/>
+              <a:rPr lang="en-US"/>
               <a:t>Click to edit Master text styles</a:t>
             </a:r>
           </a:p>
           <a:p>
             <a:pPr lvl="1"/>
             <a:r>
-              <a:rPr lang="en-US" smtClean="0"/>
+              <a:rPr lang="en-US"/>
               <a:t>Second level</a:t>
             </a:r>
           </a:p>
           <a:p>
             <a:pPr lvl="2"/>
             <a:r>
-              <a:rPr lang="en-US" smtClean="0"/>
+              <a:rPr lang="en-US"/>
               <a:t>Third level</a:t>
             </a:r>
           </a:p>
           <a:p>
             <a:pPr lvl="3"/>
             <a:r>
-              <a:rPr lang="en-US" smtClean="0"/>
+              <a:rPr lang="en-US"/>
               <a:t>Fourth level</a:t>
             </a:r>
           </a:p>
           <a:p>
             <a:pPr lvl="4"/>
             <a:r>
-              <a:rPr lang="en-US" smtClean="0"/>
+              <a:rPr lang="en-US"/>
               <a:t>Fifth level</a:t>
             </a:r>
-            <a:endParaRPr lang="en-US"/>
           </a:p>
         </p:txBody>
       </p:sp>
@@ -2981,7 +3229,7 @@
           <a:p>
             <a:pPr lvl="0"/>
             <a:r>
-              <a:rPr lang="en-US" smtClean="0"/>
+              <a:rPr lang="en-US"/>
               <a:t>Click to edit Master text styles</a:t>
             </a:r>
           </a:p>
@@ -3004,7 +3252,7 @@
           <a:p>
             <a:fld id="{5BCAD085-E8A6-8845-BD4E-CB4CCA059FC4}" type="datetimeFigureOut">
               <a:rPr lang="en-US" smtClean="0"/>
-              <a:t>1/27/13</a:t>
+              <a:t>4/27/26</a:t>
             </a:fld>
             <a:endParaRPr lang="en-US"/>
           </a:p>
@@ -3107,10 +3355,9 @@
           </a:lstStyle>
           <a:p>
             <a:r>
-              <a:rPr lang="en-US" smtClean="0"/>
+              <a:rPr lang="en-US"/>
               <a:t>Click to edit Master title style</a:t>
             </a:r>
-            <a:endParaRPr lang="en-US"/>
           </a:p>
         </p:txBody>
       </p:sp>
@@ -3234,7 +3481,7 @@
           <a:p>
             <a:pPr lvl="0"/>
             <a:r>
-              <a:rPr lang="en-US" smtClean="0"/>
+              <a:rPr lang="en-US"/>
               <a:t>Click to edit Master text styles</a:t>
             </a:r>
           </a:p>
@@ -3257,7 +3504,7 @@
           <a:p>
             <a:fld id="{5BCAD085-E8A6-8845-BD4E-CB4CCA059FC4}" type="datetimeFigureOut">
               <a:rPr lang="en-US" smtClean="0"/>
-              <a:t>1/27/13</a:t>
+              <a:t>4/27/26</a:t>
             </a:fld>
             <a:endParaRPr lang="en-US"/>
           </a:p>
@@ -3366,10 +3613,9 @@
           <a:lstStyle/>
           <a:p>
             <a:r>
-              <a:rPr lang="en-US" smtClean="0"/>
+              <a:rPr lang="en-US"/>
               <a:t>Click to edit Master title style</a:t>
             </a:r>
-            <a:endParaRPr lang="en-US"/>
           </a:p>
         </p:txBody>
       </p:sp>
@@ -3400,38 +3646,37 @@
           <a:p>
             <a:pPr lvl="0"/>
             <a:r>
-              <a:rPr lang="en-US" smtClean="0"/>
+              <a:rPr lang="en-US"/>
               <a:t>Click to edit Master text styles</a:t>
             </a:r>
           </a:p>
           <a:p>
             <a:pPr lvl="1"/>
             <a:r>
-              <a:rPr lang="en-US" smtClean="0"/>
+              <a:rPr lang="en-US"/>
               <a:t>Second level</a:t>
             </a:r>
           </a:p>
           <a:p>
             <a:pPr lvl="2"/>
             <a:r>
-              <a:rPr lang="en-US" smtClean="0"/>
+              <a:rPr lang="en-US"/>
               <a:t>Third level</a:t>
             </a:r>
           </a:p>
           <a:p>
             <a:pPr lvl="3"/>
             <a:r>
-              <a:rPr lang="en-US" smtClean="0"/>
+              <a:rPr lang="en-US"/>
               <a:t>Fourth level</a:t>
             </a:r>
           </a:p>
           <a:p>
             <a:pPr lvl="4"/>
             <a:r>
-              <a:rPr lang="en-US" smtClean="0"/>
+              <a:rPr lang="en-US"/>
               <a:t>Fifth level</a:t>
             </a:r>
-            <a:endParaRPr lang="en-US"/>
           </a:p>
         </p:txBody>
       </p:sp>
@@ -3470,7 +3715,7 @@
           <a:p>
             <a:fld id="{5BCAD085-E8A6-8845-BD4E-CB4CCA059FC4}" type="datetimeFigureOut">
               <a:rPr lang="en-US" smtClean="0"/>
-              <a:t>1/27/13</a:t>
+              <a:t>4/27/26</a:t>
             </a:fld>
             <a:endParaRPr lang="en-US"/>
           </a:p>
@@ -3829,7 +4074,7 @@
 </file>
 
 <file path=ppt/slides/slide1.xml><?xml version="1.0" encoding="utf-8"?>
-<p:sld xmlns:a="http://schemas.openxmlformats.org/drawingml/2006/main" xmlns:p="http://schemas.openxmlformats.org/presentationml/2006/main" xmlns:r="http://schemas.openxmlformats.org/officeDocument/2006/relationships">
+<p:sld xmlns:a="http://schemas.openxmlformats.org/drawingml/2006/main" xmlns:r="http://schemas.openxmlformats.org/officeDocument/2006/relationships" xmlns:p="http://schemas.openxmlformats.org/presentationml/2006/main">
   <p:cSld>
     <p:spTree>
       <p:nvGrpSpPr>
@@ -3837,7 +4082,14 @@
         <p:cNvGrpSpPr/>
         <p:nvPr/>
       </p:nvGrpSpPr>
-      <p:grpSpPr/>
+      <p:grpSpPr>
+        <a:xfrm>
+          <a:off x="0" y="0"/>
+          <a:ext cx="0" cy="0"/>
+          <a:chOff x="0" y="0"/>
+          <a:chExt cx="0" cy="0"/>
+        </a:xfrm>
+      </p:grpSpPr>
       <p:sp>
         <p:nvSpPr>
           <p:cNvPr id="2" name="Rectangle 1"/>
@@ -3878,6 +4130,7 @@
           <a:lstStyle/>
           <a:p>
             <a:pPr algn="ctr"/>
+            <a:endParaRPr/>
           </a:p>
         </p:txBody>
       </p:sp>
@@ -3921,6 +4174,7 @@
           <a:lstStyle/>
           <a:p>
             <a:pPr algn="ctr"/>
+            <a:endParaRPr/>
           </a:p>
         </p:txBody>
       </p:sp>
@@ -3964,6 +4218,7 @@
           <a:lstStyle/>
           <a:p>
             <a:pPr algn="ctr"/>
+            <a:endParaRPr/>
           </a:p>
         </p:txBody>
       </p:sp>
@@ -4007,6 +4262,7 @@
           <a:lstStyle/>
           <a:p>
             <a:pPr algn="ctr"/>
+            <a:endParaRPr/>
           </a:p>
         </p:txBody>
       </p:sp>
@@ -4050,6 +4306,7 @@
           <a:lstStyle/>
           <a:p>
             <a:pPr algn="ctr"/>
+            <a:endParaRPr/>
           </a:p>
         </p:txBody>
       </p:sp>
@@ -4093,6 +4350,7 @@
           <a:lstStyle/>
           <a:p>
             <a:pPr algn="ctr"/>
+            <a:endParaRPr/>
           </a:p>
         </p:txBody>
       </p:sp>
@@ -4238,6 +4496,7 @@
           <a:lstStyle/>
           <a:p>
             <a:pPr algn="ctr"/>
+            <a:endParaRPr/>
           </a:p>
         </p:txBody>
       </p:sp>
@@ -4265,13 +4524,26 @@
           <a:p>
             <a:pPr algn="l"/>
             <a:r>
-              <a:rPr sz="2000" b="1" i="0">
+              <a:rPr sz="2000" b="1" i="0" dirty="0">
                 <a:solidFill>
                   <a:srgbClr val="FFFFFF"/>
                 </a:solidFill>
               </a:rPr>
-              <a:t>Group 6</a:t>
-            </a:r>
+              <a:t>Group </a:t>
+            </a:r>
+            <a:r>
+              <a:rPr lang="en-US" sz="2000" b="1" i="0" dirty="0">
+                <a:solidFill>
+                  <a:srgbClr val="FFFFFF"/>
+                </a:solidFill>
+              </a:rPr>
+              <a:t>8</a:t>
+            </a:r>
+            <a:endParaRPr sz="2000" b="1" i="0" dirty="0">
+              <a:solidFill>
+                <a:srgbClr val="FFFFFF"/>
+              </a:solidFill>
+            </a:endParaRPr>
           </a:p>
         </p:txBody>
       </p:sp>
@@ -4383,6 +4655,7 @@
           <a:lstStyle/>
           <a:p>
             <a:pPr algn="ctr"/>
+            <a:endParaRPr/>
           </a:p>
         </p:txBody>
       </p:sp>
@@ -4460,6 +4733,7 @@
           <a:lstStyle/>
           <a:p>
             <a:pPr algn="ctr"/>
+            <a:endParaRPr/>
           </a:p>
         </p:txBody>
       </p:sp>
@@ -4537,6 +4811,7 @@
           <a:lstStyle/>
           <a:p>
             <a:pPr algn="ctr"/>
+            <a:endParaRPr/>
           </a:p>
         </p:txBody>
       </p:sp>
@@ -4614,6 +4889,7 @@
           <a:lstStyle/>
           <a:p>
             <a:pPr algn="ctr"/>
+            <a:endParaRPr/>
           </a:p>
         </p:txBody>
       </p:sp>
@@ -4691,6 +4967,7 @@
           <a:lstStyle/>
           <a:p>
             <a:pPr algn="ctr"/>
+            <a:endParaRPr/>
           </a:p>
         </p:txBody>
       </p:sp>
@@ -4768,6 +5045,7 @@
           <a:lstStyle/>
           <a:p>
             <a:pPr algn="ctr"/>
+            <a:endParaRPr/>
           </a:p>
         </p:txBody>
       </p:sp>
@@ -4848,7 +5126,7 @@
 </file>
 
 <file path=ppt/slides/slide10.xml><?xml version="1.0" encoding="utf-8"?>
-<p:sld xmlns:a="http://schemas.openxmlformats.org/drawingml/2006/main" xmlns:p="http://schemas.openxmlformats.org/presentationml/2006/main" xmlns:r="http://schemas.openxmlformats.org/officeDocument/2006/relationships">
+<p:sld xmlns:a="http://schemas.openxmlformats.org/drawingml/2006/main" xmlns:r="http://schemas.openxmlformats.org/officeDocument/2006/relationships" xmlns:p="http://schemas.openxmlformats.org/presentationml/2006/main">
   <p:cSld>
     <p:spTree>
       <p:nvGrpSpPr>
@@ -4856,7 +5134,14 @@
         <p:cNvGrpSpPr/>
         <p:nvPr/>
       </p:nvGrpSpPr>
-      <p:grpSpPr/>
+      <p:grpSpPr>
+        <a:xfrm>
+          <a:off x="0" y="0"/>
+          <a:ext cx="0" cy="0"/>
+          <a:chOff x="0" y="0"/>
+          <a:chExt cx="0" cy="0"/>
+        </a:xfrm>
+      </p:grpSpPr>
       <p:sp>
         <p:nvSpPr>
           <p:cNvPr id="2" name="Rectangle 1"/>
@@ -4897,6 +5182,7 @@
           <a:lstStyle/>
           <a:p>
             <a:pPr algn="ctr"/>
+            <a:endParaRPr/>
           </a:p>
         </p:txBody>
       </p:sp>
@@ -4940,6 +5226,7 @@
           <a:lstStyle/>
           <a:p>
             <a:pPr algn="ctr"/>
+            <a:endParaRPr/>
           </a:p>
         </p:txBody>
       </p:sp>
@@ -4983,6 +5270,7 @@
           <a:lstStyle/>
           <a:p>
             <a:pPr algn="ctr"/>
+            <a:endParaRPr/>
           </a:p>
         </p:txBody>
       </p:sp>
@@ -5094,6 +5382,7 @@
           <a:lstStyle/>
           <a:p>
             <a:pPr algn="ctr"/>
+            <a:endParaRPr/>
           </a:p>
         </p:txBody>
       </p:sp>
@@ -5121,13 +5410,26 @@
           <a:p>
             <a:pPr algn="l"/>
             <a:r>
-              <a:rPr sz="900" b="0" i="0">
+              <a:rPr sz="900" b="0" i="0" dirty="0">
                 <a:solidFill>
                   <a:srgbClr val="70B5F9"/>
                 </a:solidFill>
               </a:rPr>
-              <a:t>DATA 236 · LinkedIn Platform  |  Group 6</a:t>
-            </a:r>
+              <a:t>DATA 236 · LinkedIn Platform  |  Group </a:t>
+            </a:r>
+            <a:r>
+              <a:rPr lang="en-US" sz="900" b="0" i="0" dirty="0">
+                <a:solidFill>
+                  <a:srgbClr val="70B5F9"/>
+                </a:solidFill>
+              </a:rPr>
+              <a:t>8</a:t>
+            </a:r>
+            <a:endParaRPr sz="900" b="0" i="0" dirty="0">
+              <a:solidFill>
+                <a:srgbClr val="70B5F9"/>
+              </a:solidFill>
+            </a:endParaRPr>
           </a:p>
         </p:txBody>
       </p:sp>
@@ -5205,6 +5507,7 @@
           <a:lstStyle/>
           <a:p>
             <a:pPr algn="ctr"/>
+            <a:endParaRPr/>
           </a:p>
         </p:txBody>
       </p:sp>
@@ -5385,6 +5688,7 @@
           <a:lstStyle/>
           <a:p>
             <a:pPr algn="ctr"/>
+            <a:endParaRPr/>
           </a:p>
         </p:txBody>
       </p:sp>
@@ -5565,6 +5869,7 @@
           <a:lstStyle/>
           <a:p>
             <a:pPr algn="ctr"/>
+            <a:endParaRPr/>
           </a:p>
         </p:txBody>
       </p:sp>
@@ -5745,6 +6050,7 @@
           <a:lstStyle/>
           <a:p>
             <a:pPr algn="ctr"/>
+            <a:endParaRPr/>
           </a:p>
         </p:txBody>
       </p:sp>
@@ -5925,6 +6231,7 @@
           <a:lstStyle/>
           <a:p>
             <a:pPr algn="ctr"/>
+            <a:endParaRPr/>
           </a:p>
         </p:txBody>
       </p:sp>
@@ -6105,6 +6412,7 @@
           <a:lstStyle/>
           <a:p>
             <a:pPr algn="ctr"/>
+            <a:endParaRPr/>
           </a:p>
         </p:txBody>
       </p:sp>
@@ -6288,7 +6596,7 @@
 </file>
 
 <file path=ppt/slides/slide11.xml><?xml version="1.0" encoding="utf-8"?>
-<p:sld xmlns:a="http://schemas.openxmlformats.org/drawingml/2006/main" xmlns:p="http://schemas.openxmlformats.org/presentationml/2006/main" xmlns:r="http://schemas.openxmlformats.org/officeDocument/2006/relationships">
+<p:sld xmlns:a="http://schemas.openxmlformats.org/drawingml/2006/main" xmlns:r="http://schemas.openxmlformats.org/officeDocument/2006/relationships" xmlns:p="http://schemas.openxmlformats.org/presentationml/2006/main">
   <p:cSld>
     <p:spTree>
       <p:nvGrpSpPr>
@@ -6296,7 +6604,14 @@
         <p:cNvGrpSpPr/>
         <p:nvPr/>
       </p:nvGrpSpPr>
-      <p:grpSpPr/>
+      <p:grpSpPr>
+        <a:xfrm>
+          <a:off x="0" y="0"/>
+          <a:ext cx="0" cy="0"/>
+          <a:chOff x="0" y="0"/>
+          <a:chExt cx="0" cy="0"/>
+        </a:xfrm>
+      </p:grpSpPr>
       <p:sp>
         <p:nvSpPr>
           <p:cNvPr id="2" name="Rectangle 1"/>
@@ -6337,6 +6652,7 @@
           <a:lstStyle/>
           <a:p>
             <a:pPr algn="ctr"/>
+            <a:endParaRPr/>
           </a:p>
         </p:txBody>
       </p:sp>
@@ -6380,6 +6696,7 @@
           <a:lstStyle/>
           <a:p>
             <a:pPr algn="ctr"/>
+            <a:endParaRPr/>
           </a:p>
         </p:txBody>
       </p:sp>
@@ -6423,6 +6740,7 @@
           <a:lstStyle/>
           <a:p>
             <a:pPr algn="ctr"/>
+            <a:endParaRPr/>
           </a:p>
         </p:txBody>
       </p:sp>
@@ -6534,6 +6852,7 @@
           <a:lstStyle/>
           <a:p>
             <a:pPr algn="ctr"/>
+            <a:endParaRPr/>
           </a:p>
         </p:txBody>
       </p:sp>
@@ -6561,13 +6880,26 @@
           <a:p>
             <a:pPr algn="l"/>
             <a:r>
-              <a:rPr sz="900" b="0" i="0">
+              <a:rPr sz="900" b="0" i="0" dirty="0">
                 <a:solidFill>
                   <a:srgbClr val="70B5F9"/>
                 </a:solidFill>
               </a:rPr>
-              <a:t>DATA 236 · LinkedIn Platform  |  Group 6</a:t>
-            </a:r>
+              <a:t>DATA 236 · LinkedIn Platform  |  Group </a:t>
+            </a:r>
+            <a:r>
+              <a:rPr lang="en-US" sz="900" b="0" i="0" dirty="0">
+                <a:solidFill>
+                  <a:srgbClr val="70B5F9"/>
+                </a:solidFill>
+              </a:rPr>
+              <a:t>8</a:t>
+            </a:r>
+            <a:endParaRPr sz="900" b="0" i="0" dirty="0">
+              <a:solidFill>
+                <a:srgbClr val="70B5F9"/>
+              </a:solidFill>
+            </a:endParaRPr>
           </a:p>
         </p:txBody>
       </p:sp>
@@ -6619,7 +6951,7 @@
         </p:xfrm>
         <a:graphic>
           <a:graphicData uri="http://schemas.openxmlformats.org/drawingml/2006/chart">
-            <c:chart xmlns:c="http://schemas.openxmlformats.org/drawingml/2006/chart" r:id="rId2"/>
+            <c:chart xmlns:c="http://schemas.openxmlformats.org/drawingml/2006/chart" xmlns:r="http://schemas.openxmlformats.org/officeDocument/2006/relationships" r:id="rId2"/>
           </a:graphicData>
         </a:graphic>
       </p:graphicFrame>
@@ -6663,6 +6995,7 @@
           <a:lstStyle/>
           <a:p>
             <a:pPr algn="ctr"/>
+            <a:endParaRPr/>
           </a:p>
         </p:txBody>
       </p:sp>
@@ -6820,7 +7153,7 @@
         </p:xfrm>
         <a:graphic>
           <a:graphicData uri="http://schemas.openxmlformats.org/drawingml/2006/chart">
-            <c:chart xmlns:c="http://schemas.openxmlformats.org/drawingml/2006/chart" r:id="rId3"/>
+            <c:chart xmlns:c="http://schemas.openxmlformats.org/drawingml/2006/chart" xmlns:r="http://schemas.openxmlformats.org/officeDocument/2006/relationships" r:id="rId3"/>
           </a:graphicData>
         </a:graphic>
       </p:graphicFrame>
@@ -6864,6 +7197,7 @@
           <a:lstStyle/>
           <a:p>
             <a:pPr algn="ctr"/>
+            <a:endParaRPr/>
           </a:p>
         </p:txBody>
       </p:sp>
@@ -6975,6 +7309,7 @@
           <a:lstStyle/>
           <a:p>
             <a:pPr algn="ctr"/>
+            <a:endParaRPr/>
           </a:p>
         </p:txBody>
       </p:sp>
@@ -7052,6 +7387,7 @@
           <a:lstStyle/>
           <a:p>
             <a:pPr algn="ctr"/>
+            <a:endParaRPr/>
           </a:p>
         </p:txBody>
       </p:sp>
@@ -7129,6 +7465,7 @@
           <a:lstStyle/>
           <a:p>
             <a:pPr algn="ctr"/>
+            <a:endParaRPr/>
           </a:p>
         </p:txBody>
       </p:sp>
@@ -7206,6 +7543,7 @@
           <a:lstStyle/>
           <a:p>
             <a:pPr algn="ctr"/>
+            <a:endParaRPr/>
           </a:p>
         </p:txBody>
       </p:sp>
@@ -7283,6 +7621,7 @@
           <a:lstStyle/>
           <a:p>
             <a:pPr algn="ctr"/>
+            <a:endParaRPr/>
           </a:p>
         </p:txBody>
       </p:sp>
@@ -7360,6 +7699,7 @@
           <a:lstStyle/>
           <a:p>
             <a:pPr algn="ctr"/>
+            <a:endParaRPr/>
           </a:p>
         </p:txBody>
       </p:sp>
@@ -7437,6 +7777,7 @@
           <a:lstStyle/>
           <a:p>
             <a:pPr algn="ctr"/>
+            <a:endParaRPr/>
           </a:p>
         </p:txBody>
       </p:sp>
@@ -7514,6 +7855,7 @@
           <a:lstStyle/>
           <a:p>
             <a:pPr algn="ctr"/>
+            <a:endParaRPr/>
           </a:p>
         </p:txBody>
       </p:sp>
@@ -7591,6 +7933,7 @@
           <a:lstStyle/>
           <a:p>
             <a:pPr algn="ctr"/>
+            <a:endParaRPr/>
           </a:p>
         </p:txBody>
       </p:sp>
@@ -7668,6 +8011,7 @@
           <a:lstStyle/>
           <a:p>
             <a:pPr algn="ctr"/>
+            <a:endParaRPr/>
           </a:p>
         </p:txBody>
       </p:sp>
@@ -7745,6 +8089,7 @@
           <a:lstStyle/>
           <a:p>
             <a:pPr algn="ctr"/>
+            <a:endParaRPr/>
           </a:p>
         </p:txBody>
       </p:sp>
@@ -7822,6 +8167,7 @@
           <a:lstStyle/>
           <a:p>
             <a:pPr algn="ctr"/>
+            <a:endParaRPr/>
           </a:p>
         </p:txBody>
       </p:sp>
@@ -7899,6 +8245,7 @@
           <a:lstStyle/>
           <a:p>
             <a:pPr algn="ctr"/>
+            <a:endParaRPr/>
           </a:p>
         </p:txBody>
       </p:sp>
@@ -7976,6 +8323,7 @@
           <a:lstStyle/>
           <a:p>
             <a:pPr algn="ctr"/>
+            <a:endParaRPr/>
           </a:p>
         </p:txBody>
       </p:sp>
@@ -8053,6 +8401,7 @@
           <a:lstStyle/>
           <a:p>
             <a:pPr algn="ctr"/>
+            <a:endParaRPr/>
           </a:p>
         </p:txBody>
       </p:sp>
@@ -8130,6 +8479,7 @@
           <a:lstStyle/>
           <a:p>
             <a:pPr algn="ctr"/>
+            <a:endParaRPr/>
           </a:p>
         </p:txBody>
       </p:sp>
@@ -8207,6 +8557,7 @@
           <a:lstStyle/>
           <a:p>
             <a:pPr algn="ctr"/>
+            <a:endParaRPr/>
           </a:p>
         </p:txBody>
       </p:sp>
@@ -8284,6 +8635,7 @@
           <a:lstStyle/>
           <a:p>
             <a:pPr algn="ctr"/>
+            <a:endParaRPr/>
           </a:p>
         </p:txBody>
       </p:sp>
@@ -8361,6 +8713,7 @@
           <a:lstStyle/>
           <a:p>
             <a:pPr algn="ctr"/>
+            <a:endParaRPr/>
           </a:p>
         </p:txBody>
       </p:sp>
@@ -8438,6 +8791,7 @@
           <a:lstStyle/>
           <a:p>
             <a:pPr algn="ctr"/>
+            <a:endParaRPr/>
           </a:p>
         </p:txBody>
       </p:sp>
@@ -8515,6 +8869,7 @@
           <a:lstStyle/>
           <a:p>
             <a:pPr algn="ctr"/>
+            <a:endParaRPr/>
           </a:p>
         </p:txBody>
       </p:sp>
@@ -8592,6 +8947,7 @@
           <a:lstStyle/>
           <a:p>
             <a:pPr algn="ctr"/>
+            <a:endParaRPr/>
           </a:p>
         </p:txBody>
       </p:sp>
@@ -8669,6 +9025,7 @@
           <a:lstStyle/>
           <a:p>
             <a:pPr algn="ctr"/>
+            <a:endParaRPr/>
           </a:p>
         </p:txBody>
       </p:sp>
@@ -8746,6 +9103,7 @@
           <a:lstStyle/>
           <a:p>
             <a:pPr algn="ctr"/>
+            <a:endParaRPr/>
           </a:p>
         </p:txBody>
       </p:sp>
@@ -8823,6 +9181,7 @@
           <a:lstStyle/>
           <a:p>
             <a:pPr algn="ctr"/>
+            <a:endParaRPr/>
           </a:p>
         </p:txBody>
       </p:sp>
@@ -8900,6 +9259,7 @@
           <a:lstStyle/>
           <a:p>
             <a:pPr algn="ctr"/>
+            <a:endParaRPr/>
           </a:p>
         </p:txBody>
       </p:sp>
@@ -8977,6 +9337,7 @@
           <a:lstStyle/>
           <a:p>
             <a:pPr algn="ctr"/>
+            <a:endParaRPr/>
           </a:p>
         </p:txBody>
       </p:sp>
@@ -9054,6 +9415,7 @@
           <a:lstStyle/>
           <a:p>
             <a:pPr algn="ctr"/>
+            <a:endParaRPr/>
           </a:p>
         </p:txBody>
       </p:sp>
@@ -9131,6 +9493,7 @@
           <a:lstStyle/>
           <a:p>
             <a:pPr algn="ctr"/>
+            <a:endParaRPr/>
           </a:p>
         </p:txBody>
       </p:sp>
@@ -9208,6 +9571,7 @@
           <a:lstStyle/>
           <a:p>
             <a:pPr algn="ctr"/>
+            <a:endParaRPr/>
           </a:p>
         </p:txBody>
       </p:sp>
@@ -9285,6 +9649,7 @@
           <a:lstStyle/>
           <a:p>
             <a:pPr algn="ctr"/>
+            <a:endParaRPr/>
           </a:p>
         </p:txBody>
       </p:sp>
@@ -9362,6 +9727,7 @@
           <a:lstStyle/>
           <a:p>
             <a:pPr algn="ctr"/>
+            <a:endParaRPr/>
           </a:p>
         </p:txBody>
       </p:sp>
@@ -9439,6 +9805,7 @@
           <a:lstStyle/>
           <a:p>
             <a:pPr algn="ctr"/>
+            <a:endParaRPr/>
           </a:p>
         </p:txBody>
       </p:sp>
@@ -9516,6 +9883,7 @@
           <a:lstStyle/>
           <a:p>
             <a:pPr algn="ctr"/>
+            <a:endParaRPr/>
           </a:p>
         </p:txBody>
       </p:sp>
@@ -9593,6 +9961,7 @@
           <a:lstStyle/>
           <a:p>
             <a:pPr algn="ctr"/>
+            <a:endParaRPr/>
           </a:p>
         </p:txBody>
       </p:sp>
@@ -9670,6 +10039,7 @@
           <a:lstStyle/>
           <a:p>
             <a:pPr algn="ctr"/>
+            <a:endParaRPr/>
           </a:p>
         </p:txBody>
       </p:sp>
@@ -9747,6 +10117,7 @@
           <a:lstStyle/>
           <a:p>
             <a:pPr algn="ctr"/>
+            <a:endParaRPr/>
           </a:p>
         </p:txBody>
       </p:sp>
@@ -9824,6 +10195,7 @@
           <a:lstStyle/>
           <a:p>
             <a:pPr algn="ctr"/>
+            <a:endParaRPr/>
           </a:p>
         </p:txBody>
       </p:sp>
@@ -9901,6 +10273,7 @@
           <a:lstStyle/>
           <a:p>
             <a:pPr algn="ctr"/>
+            <a:endParaRPr/>
           </a:p>
         </p:txBody>
       </p:sp>
@@ -9978,6 +10351,7 @@
           <a:lstStyle/>
           <a:p>
             <a:pPr algn="ctr"/>
+            <a:endParaRPr/>
           </a:p>
         </p:txBody>
       </p:sp>
@@ -10024,7 +10398,7 @@
 </file>
 
 <file path=ppt/slides/slide12.xml><?xml version="1.0" encoding="utf-8"?>
-<p:sld xmlns:a="http://schemas.openxmlformats.org/drawingml/2006/main" xmlns:p="http://schemas.openxmlformats.org/presentationml/2006/main" xmlns:r="http://schemas.openxmlformats.org/officeDocument/2006/relationships">
+<p:sld xmlns:a="http://schemas.openxmlformats.org/drawingml/2006/main" xmlns:r="http://schemas.openxmlformats.org/officeDocument/2006/relationships" xmlns:p="http://schemas.openxmlformats.org/presentationml/2006/main">
   <p:cSld>
     <p:spTree>
       <p:nvGrpSpPr>
@@ -10032,7 +10406,14 @@
         <p:cNvGrpSpPr/>
         <p:nvPr/>
       </p:nvGrpSpPr>
-      <p:grpSpPr/>
+      <p:grpSpPr>
+        <a:xfrm>
+          <a:off x="0" y="0"/>
+          <a:ext cx="0" cy="0"/>
+          <a:chOff x="0" y="0"/>
+          <a:chExt cx="0" cy="0"/>
+        </a:xfrm>
+      </p:grpSpPr>
       <p:sp>
         <p:nvSpPr>
           <p:cNvPr id="2" name="Rectangle 1"/>
@@ -10073,6 +10454,7 @@
           <a:lstStyle/>
           <a:p>
             <a:pPr algn="ctr"/>
+            <a:endParaRPr/>
           </a:p>
         </p:txBody>
       </p:sp>
@@ -10116,6 +10498,7 @@
           <a:lstStyle/>
           <a:p>
             <a:pPr algn="ctr"/>
+            <a:endParaRPr/>
           </a:p>
         </p:txBody>
       </p:sp>
@@ -10159,6 +10542,7 @@
           <a:lstStyle/>
           <a:p>
             <a:pPr algn="ctr"/>
+            <a:endParaRPr/>
           </a:p>
         </p:txBody>
       </p:sp>
@@ -10270,6 +10654,7 @@
           <a:lstStyle/>
           <a:p>
             <a:pPr algn="ctr"/>
+            <a:endParaRPr/>
           </a:p>
         </p:txBody>
       </p:sp>
@@ -10297,13 +10682,26 @@
           <a:p>
             <a:pPr algn="l"/>
             <a:r>
-              <a:rPr sz="900" b="0" i="0">
+              <a:rPr sz="900" b="0" i="0" dirty="0">
                 <a:solidFill>
                   <a:srgbClr val="70B5F9"/>
                 </a:solidFill>
               </a:rPr>
-              <a:t>DATA 236 · LinkedIn Platform  |  Group 6</a:t>
-            </a:r>
+              <a:t>DATA 236 · LinkedIn Platform  |  Group </a:t>
+            </a:r>
+            <a:r>
+              <a:rPr lang="en-US" sz="900" b="0" i="0" dirty="0">
+                <a:solidFill>
+                  <a:srgbClr val="70B5F9"/>
+                </a:solidFill>
+              </a:rPr>
+              <a:t>8</a:t>
+            </a:r>
+            <a:endParaRPr sz="900" b="0" i="0" dirty="0">
+              <a:solidFill>
+                <a:srgbClr val="70B5F9"/>
+              </a:solidFill>
+            </a:endParaRPr>
           </a:p>
         </p:txBody>
       </p:sp>
@@ -10381,6 +10779,7 @@
           <a:lstStyle/>
           <a:p>
             <a:pPr algn="ctr"/>
+            <a:endParaRPr/>
           </a:p>
         </p:txBody>
       </p:sp>
@@ -10424,6 +10823,7 @@
           <a:lstStyle/>
           <a:p>
             <a:pPr algn="ctr"/>
+            <a:endParaRPr/>
           </a:p>
         </p:txBody>
       </p:sp>
@@ -10705,6 +11105,7 @@
           <a:lstStyle/>
           <a:p>
             <a:pPr algn="ctr"/>
+            <a:endParaRPr/>
           </a:p>
         </p:txBody>
       </p:sp>
@@ -10748,6 +11149,7 @@
           <a:lstStyle/>
           <a:p>
             <a:pPr algn="ctr"/>
+            <a:endParaRPr/>
           </a:p>
         </p:txBody>
       </p:sp>
@@ -11029,6 +11431,7 @@
           <a:lstStyle/>
           <a:p>
             <a:pPr algn="ctr"/>
+            <a:endParaRPr/>
           </a:p>
         </p:txBody>
       </p:sp>
@@ -11072,6 +11475,7 @@
           <a:lstStyle/>
           <a:p>
             <a:pPr algn="ctr"/>
+            <a:endParaRPr/>
           </a:p>
         </p:txBody>
       </p:sp>
@@ -11322,7 +11726,7 @@
 </file>
 
 <file path=ppt/slides/slide2.xml><?xml version="1.0" encoding="utf-8"?>
-<p:sld xmlns:a="http://schemas.openxmlformats.org/drawingml/2006/main" xmlns:p="http://schemas.openxmlformats.org/presentationml/2006/main" xmlns:r="http://schemas.openxmlformats.org/officeDocument/2006/relationships">
+<p:sld xmlns:a="http://schemas.openxmlformats.org/drawingml/2006/main" xmlns:r="http://schemas.openxmlformats.org/officeDocument/2006/relationships" xmlns:p="http://schemas.openxmlformats.org/presentationml/2006/main">
   <p:cSld>
     <p:spTree>
       <p:nvGrpSpPr>
@@ -11330,7 +11734,14 @@
         <p:cNvGrpSpPr/>
         <p:nvPr/>
       </p:nvGrpSpPr>
-      <p:grpSpPr/>
+      <p:grpSpPr>
+        <a:xfrm>
+          <a:off x="0" y="0"/>
+          <a:ext cx="0" cy="0"/>
+          <a:chOff x="0" y="0"/>
+          <a:chExt cx="0" cy="0"/>
+        </a:xfrm>
+      </p:grpSpPr>
       <p:sp>
         <p:nvSpPr>
           <p:cNvPr id="2" name="Rectangle 1"/>
@@ -11371,6 +11782,7 @@
           <a:lstStyle/>
           <a:p>
             <a:pPr algn="ctr"/>
+            <a:endParaRPr/>
           </a:p>
         </p:txBody>
       </p:sp>
@@ -11414,6 +11826,7 @@
           <a:lstStyle/>
           <a:p>
             <a:pPr algn="ctr"/>
+            <a:endParaRPr/>
           </a:p>
         </p:txBody>
       </p:sp>
@@ -11457,6 +11870,7 @@
           <a:lstStyle/>
           <a:p>
             <a:pPr algn="ctr"/>
+            <a:endParaRPr/>
           </a:p>
         </p:txBody>
       </p:sp>
@@ -11534,6 +11948,7 @@
           <a:lstStyle/>
           <a:p>
             <a:pPr algn="ctr"/>
+            <a:endParaRPr/>
           </a:p>
         </p:txBody>
       </p:sp>
@@ -11561,13 +11976,26 @@
           <a:p>
             <a:pPr algn="l"/>
             <a:r>
-              <a:rPr sz="900" b="0" i="0">
+              <a:rPr sz="900" b="0" i="0" dirty="0">
                 <a:solidFill>
                   <a:srgbClr val="70B5F9"/>
                 </a:solidFill>
               </a:rPr>
-              <a:t>DATA 236 · LinkedIn Platform  |  Group 6</a:t>
-            </a:r>
+              <a:t>DATA 236 · LinkedIn Platform  |  Group </a:t>
+            </a:r>
+            <a:r>
+              <a:rPr lang="en-US" sz="900" b="0" i="0" dirty="0">
+                <a:solidFill>
+                  <a:srgbClr val="70B5F9"/>
+                </a:solidFill>
+              </a:rPr>
+              <a:t>8</a:t>
+            </a:r>
+            <a:endParaRPr sz="900" b="0" i="0" dirty="0">
+              <a:solidFill>
+                <a:srgbClr val="70B5F9"/>
+              </a:solidFill>
+            </a:endParaRPr>
           </a:p>
         </p:txBody>
       </p:sp>
@@ -11645,6 +12073,7 @@
           <a:lstStyle/>
           <a:p>
             <a:pPr algn="ctr"/>
+            <a:endParaRPr/>
           </a:p>
         </p:txBody>
       </p:sp>
@@ -11688,6 +12117,7 @@
           <a:lstStyle/>
           <a:p>
             <a:pPr algn="ctr"/>
+            <a:endParaRPr/>
           </a:p>
         </p:txBody>
       </p:sp>
@@ -11731,6 +12161,7 @@
           <a:lstStyle/>
           <a:p>
             <a:pPr algn="ctr"/>
+            <a:endParaRPr/>
           </a:p>
         </p:txBody>
       </p:sp>
@@ -11842,6 +12273,7 @@
           <a:lstStyle/>
           <a:p>
             <a:pPr algn="ctr"/>
+            <a:endParaRPr/>
           </a:p>
         </p:txBody>
       </p:sp>
@@ -11885,6 +12317,7 @@
           <a:lstStyle/>
           <a:p>
             <a:pPr algn="ctr"/>
+            <a:endParaRPr/>
           </a:p>
         </p:txBody>
       </p:sp>
@@ -11928,6 +12361,7 @@
           <a:lstStyle/>
           <a:p>
             <a:pPr algn="ctr"/>
+            <a:endParaRPr/>
           </a:p>
         </p:txBody>
       </p:sp>
@@ -12039,6 +12473,7 @@
           <a:lstStyle/>
           <a:p>
             <a:pPr algn="ctr"/>
+            <a:endParaRPr/>
           </a:p>
         </p:txBody>
       </p:sp>
@@ -12082,6 +12517,7 @@
           <a:lstStyle/>
           <a:p>
             <a:pPr algn="ctr"/>
+            <a:endParaRPr/>
           </a:p>
         </p:txBody>
       </p:sp>
@@ -12125,6 +12561,7 @@
           <a:lstStyle/>
           <a:p>
             <a:pPr algn="ctr"/>
+            <a:endParaRPr/>
           </a:p>
         </p:txBody>
       </p:sp>
@@ -12236,6 +12673,7 @@
           <a:lstStyle/>
           <a:p>
             <a:pPr algn="ctr"/>
+            <a:endParaRPr/>
           </a:p>
         </p:txBody>
       </p:sp>
@@ -12279,6 +12717,7 @@
           <a:lstStyle/>
           <a:p>
             <a:pPr algn="ctr"/>
+            <a:endParaRPr/>
           </a:p>
         </p:txBody>
       </p:sp>
@@ -12322,6 +12761,7 @@
           <a:lstStyle/>
           <a:p>
             <a:pPr algn="ctr"/>
+            <a:endParaRPr/>
           </a:p>
         </p:txBody>
       </p:sp>
@@ -12433,6 +12873,7 @@
           <a:lstStyle/>
           <a:p>
             <a:pPr algn="ctr"/>
+            <a:endParaRPr/>
           </a:p>
         </p:txBody>
       </p:sp>
@@ -12476,6 +12917,7 @@
           <a:lstStyle/>
           <a:p>
             <a:pPr algn="ctr"/>
+            <a:endParaRPr/>
           </a:p>
         </p:txBody>
       </p:sp>
@@ -12519,6 +12961,7 @@
           <a:lstStyle/>
           <a:p>
             <a:pPr algn="ctr"/>
+            <a:endParaRPr/>
           </a:p>
         </p:txBody>
       </p:sp>
@@ -12630,6 +13073,7 @@
           <a:lstStyle/>
           <a:p>
             <a:pPr algn="ctr"/>
+            <a:endParaRPr/>
           </a:p>
         </p:txBody>
       </p:sp>
@@ -12673,6 +13117,7 @@
           <a:lstStyle/>
           <a:p>
             <a:pPr algn="ctr"/>
+            <a:endParaRPr/>
           </a:p>
         </p:txBody>
       </p:sp>
@@ -12716,6 +13161,7 @@
           <a:lstStyle/>
           <a:p>
             <a:pPr algn="ctr"/>
+            <a:endParaRPr/>
           </a:p>
         </p:txBody>
       </p:sp>
@@ -12827,6 +13273,7 @@
           <a:lstStyle/>
           <a:p>
             <a:pPr algn="ctr"/>
+            <a:endParaRPr/>
           </a:p>
         </p:txBody>
       </p:sp>
@@ -12870,6 +13317,7 @@
           <a:lstStyle/>
           <a:p>
             <a:pPr algn="ctr"/>
+            <a:endParaRPr/>
           </a:p>
         </p:txBody>
       </p:sp>
@@ -12913,6 +13361,7 @@
           <a:lstStyle/>
           <a:p>
             <a:pPr algn="ctr"/>
+            <a:endParaRPr/>
           </a:p>
         </p:txBody>
       </p:sp>
@@ -13024,6 +13473,7 @@
           <a:lstStyle/>
           <a:p>
             <a:pPr algn="ctr"/>
+            <a:endParaRPr/>
           </a:p>
         </p:txBody>
       </p:sp>
@@ -13067,6 +13517,7 @@
           <a:lstStyle/>
           <a:p>
             <a:pPr algn="ctr"/>
+            <a:endParaRPr/>
           </a:p>
         </p:txBody>
       </p:sp>
@@ -13110,6 +13561,7 @@
           <a:lstStyle/>
           <a:p>
             <a:pPr algn="ctr"/>
+            <a:endParaRPr/>
           </a:p>
         </p:txBody>
       </p:sp>
@@ -13224,7 +13676,7 @@
 </file>
 
 <file path=ppt/slides/slide3.xml><?xml version="1.0" encoding="utf-8"?>
-<p:sld xmlns:a="http://schemas.openxmlformats.org/drawingml/2006/main" xmlns:p="http://schemas.openxmlformats.org/presentationml/2006/main" xmlns:r="http://schemas.openxmlformats.org/officeDocument/2006/relationships">
+<p:sld xmlns:a="http://schemas.openxmlformats.org/drawingml/2006/main" xmlns:r="http://schemas.openxmlformats.org/officeDocument/2006/relationships" xmlns:p="http://schemas.openxmlformats.org/presentationml/2006/main">
   <p:cSld>
     <p:spTree>
       <p:nvGrpSpPr>
@@ -13232,7 +13684,14 @@
         <p:cNvGrpSpPr/>
         <p:nvPr/>
       </p:nvGrpSpPr>
-      <p:grpSpPr/>
+      <p:grpSpPr>
+        <a:xfrm>
+          <a:off x="0" y="0"/>
+          <a:ext cx="0" cy="0"/>
+          <a:chOff x="0" y="0"/>
+          <a:chExt cx="0" cy="0"/>
+        </a:xfrm>
+      </p:grpSpPr>
       <p:sp>
         <p:nvSpPr>
           <p:cNvPr id="2" name="Rectangle 1"/>
@@ -13273,6 +13732,7 @@
           <a:lstStyle/>
           <a:p>
             <a:pPr algn="ctr"/>
+            <a:endParaRPr/>
           </a:p>
         </p:txBody>
       </p:sp>
@@ -13316,6 +13776,7 @@
           <a:lstStyle/>
           <a:p>
             <a:pPr algn="ctr"/>
+            <a:endParaRPr/>
           </a:p>
         </p:txBody>
       </p:sp>
@@ -13359,6 +13820,7 @@
           <a:lstStyle/>
           <a:p>
             <a:pPr algn="ctr"/>
+            <a:endParaRPr/>
           </a:p>
         </p:txBody>
       </p:sp>
@@ -13470,6 +13932,7 @@
           <a:lstStyle/>
           <a:p>
             <a:pPr algn="ctr"/>
+            <a:endParaRPr/>
           </a:p>
         </p:txBody>
       </p:sp>
@@ -13497,13 +13960,26 @@
           <a:p>
             <a:pPr algn="l"/>
             <a:r>
-              <a:rPr sz="900" b="0" i="0">
+              <a:rPr sz="900" b="0" i="0" dirty="0">
                 <a:solidFill>
                   <a:srgbClr val="70B5F9"/>
                 </a:solidFill>
               </a:rPr>
-              <a:t>DATA 236 · LinkedIn Platform  |  Group 6</a:t>
-            </a:r>
+              <a:t>DATA 236 · LinkedIn Platform  |  Group </a:t>
+            </a:r>
+            <a:r>
+              <a:rPr lang="en-US" sz="900" b="0" i="0" dirty="0">
+                <a:solidFill>
+                  <a:srgbClr val="70B5F9"/>
+                </a:solidFill>
+              </a:rPr>
+              <a:t>8</a:t>
+            </a:r>
+            <a:endParaRPr sz="900" b="0" i="0" dirty="0">
+              <a:solidFill>
+                <a:srgbClr val="70B5F9"/>
+              </a:solidFill>
+            </a:endParaRPr>
           </a:p>
         </p:txBody>
       </p:sp>
@@ -13581,6 +14057,7 @@
           <a:lstStyle/>
           <a:p>
             <a:pPr algn="ctr"/>
+            <a:endParaRPr/>
           </a:p>
         </p:txBody>
       </p:sp>
@@ -13828,6 +14305,7 @@
           <a:lstStyle/>
           <a:p>
             <a:pPr algn="ctr"/>
+            <a:endParaRPr/>
           </a:p>
         </p:txBody>
       </p:sp>
@@ -14075,6 +14553,7 @@
           <a:lstStyle/>
           <a:p>
             <a:pPr algn="ctr"/>
+            <a:endParaRPr/>
           </a:p>
         </p:txBody>
       </p:sp>
@@ -14322,6 +14801,7 @@
           <a:lstStyle/>
           <a:p>
             <a:pPr algn="ctr"/>
+            <a:endParaRPr/>
           </a:p>
         </p:txBody>
       </p:sp>
@@ -14535,6 +15015,7 @@
           <a:lstStyle/>
           <a:p>
             <a:pPr algn="ctr"/>
+            <a:endParaRPr/>
           </a:p>
         </p:txBody>
       </p:sp>
@@ -14782,6 +15263,7 @@
           <a:lstStyle/>
           <a:p>
             <a:pPr algn="ctr"/>
+            <a:endParaRPr/>
           </a:p>
         </p:txBody>
       </p:sp>
@@ -15029,6 +15511,7 @@
           <a:lstStyle/>
           <a:p>
             <a:pPr algn="ctr"/>
+            <a:endParaRPr/>
           </a:p>
         </p:txBody>
       </p:sp>
@@ -15310,6 +15793,7 @@
           <a:lstStyle/>
           <a:p>
             <a:pPr algn="ctr"/>
+            <a:endParaRPr/>
           </a:p>
         </p:txBody>
       </p:sp>
@@ -15591,6 +16075,7 @@
           <a:lstStyle/>
           <a:p>
             <a:pPr algn="ctr"/>
+            <a:endParaRPr/>
           </a:p>
         </p:txBody>
       </p:sp>
@@ -15841,7 +16326,7 @@
 </file>
 
 <file path=ppt/slides/slide4.xml><?xml version="1.0" encoding="utf-8"?>
-<p:sld xmlns:a="http://schemas.openxmlformats.org/drawingml/2006/main" xmlns:p="http://schemas.openxmlformats.org/presentationml/2006/main" xmlns:r="http://schemas.openxmlformats.org/officeDocument/2006/relationships">
+<p:sld xmlns:a="http://schemas.openxmlformats.org/drawingml/2006/main" xmlns:r="http://schemas.openxmlformats.org/officeDocument/2006/relationships" xmlns:p="http://schemas.openxmlformats.org/presentationml/2006/main">
   <p:cSld>
     <p:spTree>
       <p:nvGrpSpPr>
@@ -15849,7 +16334,14 @@
         <p:cNvGrpSpPr/>
         <p:nvPr/>
       </p:nvGrpSpPr>
-      <p:grpSpPr/>
+      <p:grpSpPr>
+        <a:xfrm>
+          <a:off x="0" y="0"/>
+          <a:ext cx="0" cy="0"/>
+          <a:chOff x="0" y="0"/>
+          <a:chExt cx="0" cy="0"/>
+        </a:xfrm>
+      </p:grpSpPr>
       <p:sp>
         <p:nvSpPr>
           <p:cNvPr id="2" name="Rectangle 1"/>
@@ -15890,6 +16382,7 @@
           <a:lstStyle/>
           <a:p>
             <a:pPr algn="ctr"/>
+            <a:endParaRPr/>
           </a:p>
         </p:txBody>
       </p:sp>
@@ -15933,6 +16426,7 @@
           <a:lstStyle/>
           <a:p>
             <a:pPr algn="ctr"/>
+            <a:endParaRPr/>
           </a:p>
         </p:txBody>
       </p:sp>
@@ -15976,6 +16470,7 @@
           <a:lstStyle/>
           <a:p>
             <a:pPr algn="ctr"/>
+            <a:endParaRPr/>
           </a:p>
         </p:txBody>
       </p:sp>
@@ -16087,6 +16582,7 @@
           <a:lstStyle/>
           <a:p>
             <a:pPr algn="ctr"/>
+            <a:endParaRPr/>
           </a:p>
         </p:txBody>
       </p:sp>
@@ -16114,13 +16610,26 @@
           <a:p>
             <a:pPr algn="l"/>
             <a:r>
-              <a:rPr sz="900" b="0" i="0">
+              <a:rPr sz="900" b="0" i="0" dirty="0">
                 <a:solidFill>
                   <a:srgbClr val="70B5F9"/>
                 </a:solidFill>
               </a:rPr>
-              <a:t>DATA 236 · LinkedIn Platform  |  Group 6</a:t>
-            </a:r>
+              <a:t>DATA 236 · LinkedIn Platform  |  Group </a:t>
+            </a:r>
+            <a:r>
+              <a:rPr lang="en-US" sz="900" b="0" i="0" dirty="0">
+                <a:solidFill>
+                  <a:srgbClr val="70B5F9"/>
+                </a:solidFill>
+              </a:rPr>
+              <a:t>8</a:t>
+            </a:r>
+            <a:endParaRPr sz="900" b="0" i="0" dirty="0">
+              <a:solidFill>
+                <a:srgbClr val="70B5F9"/>
+              </a:solidFill>
+            </a:endParaRPr>
           </a:p>
         </p:txBody>
       </p:sp>
@@ -16198,6 +16707,7 @@
           <a:lstStyle/>
           <a:p>
             <a:pPr algn="ctr"/>
+            <a:endParaRPr/>
           </a:p>
         </p:txBody>
       </p:sp>
@@ -16276,6 +16786,7 @@
           <a:lstStyle/>
           <a:p>
             <a:pPr algn="ctr"/>
+            <a:endParaRPr/>
           </a:p>
         </p:txBody>
       </p:sp>
@@ -16354,6 +16865,7 @@
           <a:lstStyle/>
           <a:p>
             <a:pPr algn="ctr"/>
+            <a:endParaRPr/>
           </a:p>
         </p:txBody>
       </p:sp>
@@ -16431,6 +16943,7 @@
           <a:lstStyle/>
           <a:p>
             <a:pPr algn="ctr"/>
+            <a:endParaRPr/>
           </a:p>
         </p:txBody>
       </p:sp>
@@ -16509,6 +17022,7 @@
           <a:lstStyle/>
           <a:p>
             <a:pPr algn="ctr"/>
+            <a:endParaRPr/>
           </a:p>
         </p:txBody>
       </p:sp>
@@ -16587,6 +17101,7 @@
           <a:lstStyle/>
           <a:p>
             <a:pPr algn="ctr"/>
+            <a:endParaRPr/>
           </a:p>
         </p:txBody>
       </p:sp>
@@ -16666,6 +17181,7 @@
           <a:lstStyle/>
           <a:p>
             <a:pPr algn="ctr"/>
+            <a:endParaRPr/>
           </a:p>
         </p:txBody>
       </p:sp>
@@ -16744,6 +17260,7 @@
           <a:lstStyle/>
           <a:p>
             <a:pPr algn="ctr"/>
+            <a:endParaRPr/>
           </a:p>
         </p:txBody>
       </p:sp>
@@ -16858,6 +17375,7 @@
           <a:lstStyle/>
           <a:p>
             <a:pPr algn="ctr"/>
+            <a:endParaRPr/>
           </a:p>
         </p:txBody>
       </p:sp>
@@ -16937,6 +17455,7 @@
           <a:lstStyle/>
           <a:p>
             <a:pPr algn="ctr"/>
+            <a:endParaRPr/>
           </a:p>
         </p:txBody>
       </p:sp>
@@ -17016,6 +17535,7 @@
           <a:lstStyle/>
           <a:p>
             <a:pPr algn="ctr"/>
+            <a:endParaRPr/>
           </a:p>
         </p:txBody>
       </p:sp>
@@ -17095,6 +17615,7 @@
           <a:lstStyle/>
           <a:p>
             <a:pPr algn="ctr"/>
+            <a:endParaRPr/>
           </a:p>
         </p:txBody>
       </p:sp>
@@ -17174,6 +17695,7 @@
           <a:lstStyle/>
           <a:p>
             <a:pPr algn="ctr"/>
+            <a:endParaRPr/>
           </a:p>
         </p:txBody>
       </p:sp>
@@ -17253,6 +17775,7 @@
           <a:lstStyle/>
           <a:p>
             <a:pPr algn="ctr"/>
+            <a:endParaRPr/>
           </a:p>
         </p:txBody>
       </p:sp>
@@ -17332,6 +17855,7 @@
           <a:lstStyle/>
           <a:p>
             <a:pPr algn="ctr"/>
+            <a:endParaRPr/>
           </a:p>
         </p:txBody>
       </p:sp>
@@ -17411,6 +17935,7 @@
           <a:lstStyle/>
           <a:p>
             <a:pPr algn="ctr"/>
+            <a:endParaRPr/>
           </a:p>
         </p:txBody>
       </p:sp>
@@ -17490,6 +18015,7 @@
           <a:lstStyle/>
           <a:p>
             <a:pPr algn="ctr"/>
+            <a:endParaRPr/>
           </a:p>
         </p:txBody>
       </p:sp>
@@ -17569,6 +18095,7 @@
           <a:lstStyle/>
           <a:p>
             <a:pPr algn="ctr"/>
+            <a:endParaRPr/>
           </a:p>
         </p:txBody>
       </p:sp>
@@ -17646,6 +18173,7 @@
           <a:lstStyle/>
           <a:p>
             <a:pPr algn="ctr"/>
+            <a:endParaRPr/>
           </a:p>
         </p:txBody>
       </p:sp>
@@ -17723,6 +18251,7 @@
           <a:lstStyle/>
           <a:p>
             <a:pPr algn="ctr"/>
+            <a:endParaRPr/>
           </a:p>
         </p:txBody>
       </p:sp>
@@ -17800,6 +18329,7 @@
           <a:lstStyle/>
           <a:p>
             <a:pPr algn="ctr"/>
+            <a:endParaRPr/>
           </a:p>
         </p:txBody>
       </p:sp>
@@ -17877,6 +18407,7 @@
           <a:lstStyle/>
           <a:p>
             <a:pPr algn="ctr"/>
+            <a:endParaRPr/>
           </a:p>
         </p:txBody>
       </p:sp>
@@ -17954,6 +18485,7 @@
           <a:lstStyle/>
           <a:p>
             <a:pPr algn="ctr"/>
+            <a:endParaRPr/>
           </a:p>
         </p:txBody>
       </p:sp>
@@ -18031,6 +18563,7 @@
           <a:lstStyle/>
           <a:p>
             <a:pPr algn="ctr"/>
+            <a:endParaRPr/>
           </a:p>
         </p:txBody>
       </p:sp>
@@ -18108,6 +18641,7 @@
           <a:lstStyle/>
           <a:p>
             <a:pPr algn="ctr"/>
+            <a:endParaRPr/>
           </a:p>
         </p:txBody>
       </p:sp>
@@ -18185,6 +18719,7 @@
           <a:lstStyle/>
           <a:p>
             <a:pPr algn="ctr"/>
+            <a:endParaRPr/>
           </a:p>
         </p:txBody>
       </p:sp>
@@ -18262,6 +18797,7 @@
           <a:lstStyle/>
           <a:p>
             <a:pPr algn="ctr"/>
+            <a:endParaRPr/>
           </a:p>
         </p:txBody>
       </p:sp>
@@ -18339,6 +18875,7 @@
           <a:lstStyle/>
           <a:p>
             <a:pPr algn="ctr"/>
+            <a:endParaRPr/>
           </a:p>
         </p:txBody>
       </p:sp>
@@ -18416,6 +18953,7 @@
           <a:lstStyle/>
           <a:p>
             <a:pPr algn="ctr"/>
+            <a:endParaRPr/>
           </a:p>
         </p:txBody>
       </p:sp>
@@ -18493,6 +19031,7 @@
           <a:lstStyle/>
           <a:p>
             <a:pPr algn="ctr"/>
+            <a:endParaRPr/>
           </a:p>
         </p:txBody>
       </p:sp>
@@ -18570,6 +19109,7 @@
           <a:lstStyle/>
           <a:p>
             <a:pPr algn="ctr"/>
+            <a:endParaRPr/>
           </a:p>
         </p:txBody>
       </p:sp>
@@ -18647,6 +19187,7 @@
           <a:lstStyle/>
           <a:p>
             <a:pPr algn="ctr"/>
+            <a:endParaRPr/>
           </a:p>
         </p:txBody>
       </p:sp>
@@ -18728,6 +19269,7 @@
           <a:lstStyle/>
           <a:p>
             <a:pPr algn="ctr"/>
+            <a:endParaRPr/>
           </a:p>
         </p:txBody>
       </p:sp>
@@ -18808,6 +19350,7 @@
           <a:lstStyle/>
           <a:p>
             <a:pPr algn="ctr"/>
+            <a:endParaRPr/>
           </a:p>
         </p:txBody>
       </p:sp>
@@ -18857,7 +19400,7 @@
 </file>
 
 <file path=ppt/slides/slide5.xml><?xml version="1.0" encoding="utf-8"?>
-<p:sld xmlns:a="http://schemas.openxmlformats.org/drawingml/2006/main" xmlns:p="http://schemas.openxmlformats.org/presentationml/2006/main" xmlns:r="http://schemas.openxmlformats.org/officeDocument/2006/relationships">
+<p:sld xmlns:a="http://schemas.openxmlformats.org/drawingml/2006/main" xmlns:r="http://schemas.openxmlformats.org/officeDocument/2006/relationships" xmlns:p="http://schemas.openxmlformats.org/presentationml/2006/main">
   <p:cSld>
     <p:spTree>
       <p:nvGrpSpPr>
@@ -18865,7 +19408,14 @@
         <p:cNvGrpSpPr/>
         <p:nvPr/>
       </p:nvGrpSpPr>
-      <p:grpSpPr/>
+      <p:grpSpPr>
+        <a:xfrm>
+          <a:off x="0" y="0"/>
+          <a:ext cx="0" cy="0"/>
+          <a:chOff x="0" y="0"/>
+          <a:chExt cx="0" cy="0"/>
+        </a:xfrm>
+      </p:grpSpPr>
       <p:sp>
         <p:nvSpPr>
           <p:cNvPr id="2" name="Rectangle 1"/>
@@ -18906,6 +19456,7 @@
           <a:lstStyle/>
           <a:p>
             <a:pPr algn="ctr"/>
+            <a:endParaRPr/>
           </a:p>
         </p:txBody>
       </p:sp>
@@ -18949,6 +19500,7 @@
           <a:lstStyle/>
           <a:p>
             <a:pPr algn="ctr"/>
+            <a:endParaRPr/>
           </a:p>
         </p:txBody>
       </p:sp>
@@ -18992,6 +19544,7 @@
           <a:lstStyle/>
           <a:p>
             <a:pPr algn="ctr"/>
+            <a:endParaRPr/>
           </a:p>
         </p:txBody>
       </p:sp>
@@ -19103,6 +19656,7 @@
           <a:lstStyle/>
           <a:p>
             <a:pPr algn="ctr"/>
+            <a:endParaRPr/>
           </a:p>
         </p:txBody>
       </p:sp>
@@ -19130,13 +19684,26 @@
           <a:p>
             <a:pPr algn="l"/>
             <a:r>
-              <a:rPr sz="900" b="0" i="0">
+              <a:rPr sz="900" b="0" i="0" dirty="0">
                 <a:solidFill>
                   <a:srgbClr val="70B5F9"/>
                 </a:solidFill>
               </a:rPr>
-              <a:t>DATA 236 · LinkedIn Platform  |  Group 6</a:t>
-            </a:r>
+              <a:t>DATA 236 · LinkedIn Platform  |  Group </a:t>
+            </a:r>
+            <a:r>
+              <a:rPr lang="en-US" sz="900" b="0" i="0" dirty="0">
+                <a:solidFill>
+                  <a:srgbClr val="70B5F9"/>
+                </a:solidFill>
+              </a:rPr>
+              <a:t>8</a:t>
+            </a:r>
+            <a:endParaRPr sz="900" b="0" i="0" dirty="0">
+              <a:solidFill>
+                <a:srgbClr val="70B5F9"/>
+              </a:solidFill>
+            </a:endParaRPr>
           </a:p>
         </p:txBody>
       </p:sp>
@@ -19214,6 +19781,7 @@
           <a:lstStyle/>
           <a:p>
             <a:pPr algn="ctr"/>
+            <a:endParaRPr/>
           </a:p>
         </p:txBody>
       </p:sp>
@@ -19327,6 +19895,7 @@
           <a:lstStyle/>
           <a:p>
             <a:pPr algn="ctr"/>
+            <a:endParaRPr/>
           </a:p>
         </p:txBody>
       </p:sp>
@@ -19440,6 +20009,7 @@
           <a:lstStyle/>
           <a:p>
             <a:pPr algn="ctr"/>
+            <a:endParaRPr/>
           </a:p>
         </p:txBody>
       </p:sp>
@@ -19553,6 +20123,7 @@
           <a:lstStyle/>
           <a:p>
             <a:pPr algn="ctr"/>
+            <a:endParaRPr/>
           </a:p>
         </p:txBody>
       </p:sp>
@@ -19666,6 +20237,7 @@
           <a:lstStyle/>
           <a:p>
             <a:pPr algn="ctr"/>
+            <a:endParaRPr/>
           </a:p>
         </p:txBody>
       </p:sp>
@@ -19779,6 +20351,7 @@
           <a:lstStyle/>
           <a:p>
             <a:pPr algn="ctr"/>
+            <a:endParaRPr/>
           </a:p>
         </p:txBody>
       </p:sp>
@@ -19892,6 +20465,7 @@
           <a:lstStyle/>
           <a:p>
             <a:pPr algn="ctr"/>
+            <a:endParaRPr/>
           </a:p>
         </p:txBody>
       </p:sp>
@@ -20004,6 +20578,7 @@
           <a:lstStyle/>
           <a:p>
             <a:pPr algn="ctr"/>
+            <a:endParaRPr/>
           </a:p>
         </p:txBody>
       </p:sp>
@@ -20285,6 +20860,7 @@
           <a:lstStyle/>
           <a:p>
             <a:pPr algn="ctr"/>
+            <a:endParaRPr/>
           </a:p>
         </p:txBody>
       </p:sp>
@@ -20566,6 +21142,7 @@
           <a:lstStyle/>
           <a:p>
             <a:pPr algn="ctr"/>
+            <a:endParaRPr/>
           </a:p>
         </p:txBody>
       </p:sp>
@@ -20646,7 +21223,7 @@
 </file>
 
 <file path=ppt/slides/slide6.xml><?xml version="1.0" encoding="utf-8"?>
-<p:sld xmlns:a="http://schemas.openxmlformats.org/drawingml/2006/main" xmlns:p="http://schemas.openxmlformats.org/presentationml/2006/main" xmlns:r="http://schemas.openxmlformats.org/officeDocument/2006/relationships">
+<p:sld xmlns:a="http://schemas.openxmlformats.org/drawingml/2006/main" xmlns:r="http://schemas.openxmlformats.org/officeDocument/2006/relationships" xmlns:p="http://schemas.openxmlformats.org/presentationml/2006/main">
   <p:cSld>
     <p:spTree>
       <p:nvGrpSpPr>
@@ -20654,7 +21231,14 @@
         <p:cNvGrpSpPr/>
         <p:nvPr/>
       </p:nvGrpSpPr>
-      <p:grpSpPr/>
+      <p:grpSpPr>
+        <a:xfrm>
+          <a:off x="0" y="0"/>
+          <a:ext cx="0" cy="0"/>
+          <a:chOff x="0" y="0"/>
+          <a:chExt cx="0" cy="0"/>
+        </a:xfrm>
+      </p:grpSpPr>
       <p:sp>
         <p:nvSpPr>
           <p:cNvPr id="2" name="Rectangle 1"/>
@@ -20695,6 +21279,7 @@
           <a:lstStyle/>
           <a:p>
             <a:pPr algn="ctr"/>
+            <a:endParaRPr/>
           </a:p>
         </p:txBody>
       </p:sp>
@@ -20738,6 +21323,7 @@
           <a:lstStyle/>
           <a:p>
             <a:pPr algn="ctr"/>
+            <a:endParaRPr/>
           </a:p>
         </p:txBody>
       </p:sp>
@@ -20781,6 +21367,7 @@
           <a:lstStyle/>
           <a:p>
             <a:pPr algn="ctr"/>
+            <a:endParaRPr/>
           </a:p>
         </p:txBody>
       </p:sp>
@@ -20892,6 +21479,7 @@
           <a:lstStyle/>
           <a:p>
             <a:pPr algn="ctr"/>
+            <a:endParaRPr/>
           </a:p>
         </p:txBody>
       </p:sp>
@@ -20919,13 +21507,26 @@
           <a:p>
             <a:pPr algn="l"/>
             <a:r>
-              <a:rPr sz="900" b="0" i="0">
+              <a:rPr sz="900" b="0" i="0" dirty="0">
                 <a:solidFill>
                   <a:srgbClr val="70B5F9"/>
                 </a:solidFill>
               </a:rPr>
-              <a:t>DATA 236 · LinkedIn Platform  |  Group 6</a:t>
-            </a:r>
+              <a:t>DATA 236 · LinkedIn Platform  |  Group </a:t>
+            </a:r>
+            <a:r>
+              <a:rPr lang="en-US" sz="900" b="0" i="0" dirty="0">
+                <a:solidFill>
+                  <a:srgbClr val="70B5F9"/>
+                </a:solidFill>
+              </a:rPr>
+              <a:t>8</a:t>
+            </a:r>
+            <a:endParaRPr sz="900" b="0" i="0" dirty="0">
+              <a:solidFill>
+                <a:srgbClr val="70B5F9"/>
+              </a:solidFill>
+            </a:endParaRPr>
           </a:p>
         </p:txBody>
       </p:sp>
@@ -21003,6 +21604,7 @@
           <a:lstStyle/>
           <a:p>
             <a:pPr algn="ctr"/>
+            <a:endParaRPr/>
           </a:p>
         </p:txBody>
       </p:sp>
@@ -21196,7 +21798,7 @@
         </p:xfrm>
         <a:graphic>
           <a:graphicData uri="http://schemas.openxmlformats.org/drawingml/2006/chart">
-            <c:chart xmlns:c="http://schemas.openxmlformats.org/drawingml/2006/chart" r:id="rId2"/>
+            <c:chart xmlns:c="http://schemas.openxmlformats.org/drawingml/2006/chart" xmlns:r="http://schemas.openxmlformats.org/officeDocument/2006/relationships" r:id="rId2"/>
           </a:graphicData>
         </a:graphic>
       </p:graphicFrame>
@@ -21214,7 +21816,7 @@
         </p:xfrm>
         <a:graphic>
           <a:graphicData uri="http://schemas.openxmlformats.org/drawingml/2006/chart">
-            <c:chart xmlns:c="http://schemas.openxmlformats.org/drawingml/2006/chart" r:id="rId3"/>
+            <c:chart xmlns:c="http://schemas.openxmlformats.org/drawingml/2006/chart" xmlns:r="http://schemas.openxmlformats.org/officeDocument/2006/relationships" r:id="rId3"/>
           </a:graphicData>
         </a:graphic>
       </p:graphicFrame>
@@ -21258,6 +21860,7 @@
           <a:lstStyle/>
           <a:p>
             <a:pPr algn="ctr"/>
+            <a:endParaRPr/>
           </a:p>
         </p:txBody>
       </p:sp>
@@ -21369,6 +21972,7 @@
           <a:lstStyle/>
           <a:p>
             <a:pPr algn="ctr"/>
+            <a:endParaRPr/>
           </a:p>
         </p:txBody>
       </p:sp>
@@ -21412,6 +22016,7 @@
           <a:lstStyle/>
           <a:p>
             <a:pPr algn="ctr"/>
+            <a:endParaRPr/>
           </a:p>
         </p:txBody>
       </p:sp>
@@ -21523,6 +22128,7 @@
           <a:lstStyle/>
           <a:p>
             <a:pPr algn="ctr"/>
+            <a:endParaRPr/>
           </a:p>
         </p:txBody>
       </p:sp>
@@ -21566,6 +22172,7 @@
           <a:lstStyle/>
           <a:p>
             <a:pPr algn="ctr"/>
+            <a:endParaRPr/>
           </a:p>
         </p:txBody>
       </p:sp>
@@ -21677,6 +22284,7 @@
           <a:lstStyle/>
           <a:p>
             <a:pPr algn="ctr"/>
+            <a:endParaRPr/>
           </a:p>
         </p:txBody>
       </p:sp>
@@ -21720,6 +22328,7 @@
           <a:lstStyle/>
           <a:p>
             <a:pPr algn="ctr"/>
+            <a:endParaRPr/>
           </a:p>
         </p:txBody>
       </p:sp>
@@ -21831,6 +22440,7 @@
           <a:lstStyle/>
           <a:p>
             <a:pPr algn="ctr"/>
+            <a:endParaRPr/>
           </a:p>
         </p:txBody>
       </p:sp>
@@ -21874,6 +22484,7 @@
           <a:lstStyle/>
           <a:p>
             <a:pPr algn="ctr"/>
+            <a:endParaRPr/>
           </a:p>
         </p:txBody>
       </p:sp>
@@ -21985,6 +22596,7 @@
           <a:lstStyle/>
           <a:p>
             <a:pPr algn="ctr"/>
+            <a:endParaRPr/>
           </a:p>
         </p:txBody>
       </p:sp>
@@ -22028,6 +22640,7 @@
           <a:lstStyle/>
           <a:p>
             <a:pPr algn="ctr"/>
+            <a:endParaRPr/>
           </a:p>
         </p:txBody>
       </p:sp>
@@ -22108,7 +22721,7 @@
 </file>
 
 <file path=ppt/slides/slide7.xml><?xml version="1.0" encoding="utf-8"?>
-<p:sld xmlns:a="http://schemas.openxmlformats.org/drawingml/2006/main" xmlns:p="http://schemas.openxmlformats.org/presentationml/2006/main" xmlns:r="http://schemas.openxmlformats.org/officeDocument/2006/relationships">
+<p:sld xmlns:a="http://schemas.openxmlformats.org/drawingml/2006/main" xmlns:r="http://schemas.openxmlformats.org/officeDocument/2006/relationships" xmlns:p="http://schemas.openxmlformats.org/presentationml/2006/main">
   <p:cSld>
     <p:spTree>
       <p:nvGrpSpPr>
@@ -22116,7 +22729,14 @@
         <p:cNvGrpSpPr/>
         <p:nvPr/>
       </p:nvGrpSpPr>
-      <p:grpSpPr/>
+      <p:grpSpPr>
+        <a:xfrm>
+          <a:off x="0" y="0"/>
+          <a:ext cx="0" cy="0"/>
+          <a:chOff x="0" y="0"/>
+          <a:chExt cx="0" cy="0"/>
+        </a:xfrm>
+      </p:grpSpPr>
       <p:sp>
         <p:nvSpPr>
           <p:cNvPr id="2" name="Rectangle 1"/>
@@ -22157,6 +22777,7 @@
           <a:lstStyle/>
           <a:p>
             <a:pPr algn="ctr"/>
+            <a:endParaRPr/>
           </a:p>
         </p:txBody>
       </p:sp>
@@ -22200,6 +22821,7 @@
           <a:lstStyle/>
           <a:p>
             <a:pPr algn="ctr"/>
+            <a:endParaRPr/>
           </a:p>
         </p:txBody>
       </p:sp>
@@ -22243,6 +22865,7 @@
           <a:lstStyle/>
           <a:p>
             <a:pPr algn="ctr"/>
+            <a:endParaRPr/>
           </a:p>
         </p:txBody>
       </p:sp>
@@ -22354,6 +22977,7 @@
           <a:lstStyle/>
           <a:p>
             <a:pPr algn="ctr"/>
+            <a:endParaRPr/>
           </a:p>
         </p:txBody>
       </p:sp>
@@ -22381,13 +23005,26 @@
           <a:p>
             <a:pPr algn="l"/>
             <a:r>
-              <a:rPr sz="900" b="0" i="0">
+              <a:rPr sz="900" b="0" i="0" dirty="0">
                 <a:solidFill>
                   <a:srgbClr val="70B5F9"/>
                 </a:solidFill>
               </a:rPr>
-              <a:t>DATA 236 · LinkedIn Platform  |  Group 6</a:t>
-            </a:r>
+              <a:t>DATA 236 · LinkedIn Platform  |  Group </a:t>
+            </a:r>
+            <a:r>
+              <a:rPr lang="en-US" sz="900" b="0" i="0" dirty="0">
+                <a:solidFill>
+                  <a:srgbClr val="70B5F9"/>
+                </a:solidFill>
+              </a:rPr>
+              <a:t>8</a:t>
+            </a:r>
+            <a:endParaRPr sz="900" b="0" i="0" dirty="0">
+              <a:solidFill>
+                <a:srgbClr val="70B5F9"/>
+              </a:solidFill>
+            </a:endParaRPr>
           </a:p>
         </p:txBody>
       </p:sp>
@@ -22465,6 +23102,7 @@
           <a:lstStyle/>
           <a:p>
             <a:pPr algn="ctr"/>
+            <a:endParaRPr/>
           </a:p>
         </p:txBody>
       </p:sp>
@@ -22612,6 +23250,7 @@
           <a:lstStyle/>
           <a:p>
             <a:pPr algn="ctr"/>
+            <a:endParaRPr/>
           </a:p>
         </p:txBody>
       </p:sp>
@@ -22758,6 +23397,7 @@
           <a:lstStyle/>
           <a:p>
             <a:pPr algn="ctr"/>
+            <a:endParaRPr/>
           </a:p>
         </p:txBody>
       </p:sp>
@@ -22904,6 +23544,7 @@
           <a:lstStyle/>
           <a:p>
             <a:pPr algn="ctr"/>
+            <a:endParaRPr/>
           </a:p>
         </p:txBody>
       </p:sp>
@@ -23050,6 +23691,7 @@
           <a:lstStyle/>
           <a:p>
             <a:pPr algn="ctr"/>
+            <a:endParaRPr/>
           </a:p>
         </p:txBody>
       </p:sp>
@@ -23093,6 +23735,7 @@
           <a:lstStyle/>
           <a:p>
             <a:pPr algn="ctr"/>
+            <a:endParaRPr/>
           </a:p>
         </p:txBody>
       </p:sp>
@@ -23442,6 +24085,7 @@
           <a:lstStyle/>
           <a:p>
             <a:pPr algn="ctr"/>
+            <a:endParaRPr/>
           </a:p>
         </p:txBody>
       </p:sp>
@@ -23485,6 +24129,7 @@
           <a:lstStyle/>
           <a:p>
             <a:pPr algn="ctr"/>
+            <a:endParaRPr/>
           </a:p>
         </p:txBody>
       </p:sp>
@@ -23803,7 +24448,7 @@
 </file>
 
 <file path=ppt/slides/slide8.xml><?xml version="1.0" encoding="utf-8"?>
-<p:sld xmlns:a="http://schemas.openxmlformats.org/drawingml/2006/main" xmlns:p="http://schemas.openxmlformats.org/presentationml/2006/main" xmlns:r="http://schemas.openxmlformats.org/officeDocument/2006/relationships">
+<p:sld xmlns:a="http://schemas.openxmlformats.org/drawingml/2006/main" xmlns:r="http://schemas.openxmlformats.org/officeDocument/2006/relationships" xmlns:p="http://schemas.openxmlformats.org/presentationml/2006/main">
   <p:cSld>
     <p:spTree>
       <p:nvGrpSpPr>
@@ -23811,7 +24456,14 @@
         <p:cNvGrpSpPr/>
         <p:nvPr/>
       </p:nvGrpSpPr>
-      <p:grpSpPr/>
+      <p:grpSpPr>
+        <a:xfrm>
+          <a:off x="0" y="0"/>
+          <a:ext cx="0" cy="0"/>
+          <a:chOff x="0" y="0"/>
+          <a:chExt cx="0" cy="0"/>
+        </a:xfrm>
+      </p:grpSpPr>
       <p:sp>
         <p:nvSpPr>
           <p:cNvPr id="2" name="Rectangle 1"/>
@@ -23852,6 +24504,7 @@
           <a:lstStyle/>
           <a:p>
             <a:pPr algn="ctr"/>
+            <a:endParaRPr/>
           </a:p>
         </p:txBody>
       </p:sp>
@@ -23895,6 +24548,7 @@
           <a:lstStyle/>
           <a:p>
             <a:pPr algn="ctr"/>
+            <a:endParaRPr/>
           </a:p>
         </p:txBody>
       </p:sp>
@@ -23922,13 +24576,26 @@
           <a:p>
             <a:pPr algn="l"/>
             <a:r>
-              <a:rPr sz="900" b="0" i="0">
+              <a:rPr sz="900" b="0" i="0" dirty="0">
                 <a:solidFill>
                   <a:srgbClr val="70B5F9"/>
                 </a:solidFill>
               </a:rPr>
-              <a:t>DATA 236 · LinkedIn Platform  |  Group 6</a:t>
-            </a:r>
+              <a:t>DATA 236 · LinkedIn Platform  |  Group </a:t>
+            </a:r>
+            <a:r>
+              <a:rPr lang="en-US" sz="900" b="0" i="0" dirty="0">
+                <a:solidFill>
+                  <a:srgbClr val="70B5F9"/>
+                </a:solidFill>
+              </a:rPr>
+              <a:t>8</a:t>
+            </a:r>
+            <a:endParaRPr sz="900" b="0" i="0" dirty="0">
+              <a:solidFill>
+                <a:srgbClr val="70B5F9"/>
+              </a:solidFill>
+            </a:endParaRPr>
           </a:p>
         </p:txBody>
       </p:sp>
@@ -24006,6 +24673,7 @@
           <a:lstStyle/>
           <a:p>
             <a:pPr algn="ctr"/>
+            <a:endParaRPr/>
           </a:p>
         </p:txBody>
       </p:sp>
@@ -24049,6 +24717,7 @@
           <a:lstStyle/>
           <a:p>
             <a:pPr algn="ctr"/>
+            <a:endParaRPr/>
           </a:p>
         </p:txBody>
       </p:sp>
@@ -24160,6 +24829,7 @@
           <a:lstStyle/>
           <a:p>
             <a:pPr algn="ctr"/>
+            <a:endParaRPr/>
           </a:p>
         </p:txBody>
       </p:sp>
@@ -24273,6 +24943,7 @@
           <a:lstStyle/>
           <a:p>
             <a:pPr algn="ctr"/>
+            <a:endParaRPr/>
           </a:p>
         </p:txBody>
       </p:sp>
@@ -24386,6 +25057,7 @@
           <a:lstStyle/>
           <a:p>
             <a:pPr algn="ctr"/>
+            <a:endParaRPr/>
           </a:p>
         </p:txBody>
       </p:sp>
@@ -24499,6 +25171,7 @@
           <a:lstStyle/>
           <a:p>
             <a:pPr algn="ctr"/>
+            <a:endParaRPr/>
           </a:p>
         </p:txBody>
       </p:sp>
@@ -24612,6 +25285,7 @@
           <a:lstStyle/>
           <a:p>
             <a:pPr algn="ctr"/>
+            <a:endParaRPr/>
           </a:p>
         </p:txBody>
       </p:sp>
@@ -24725,6 +25399,7 @@
           <a:lstStyle/>
           <a:p>
             <a:pPr algn="ctr"/>
+            <a:endParaRPr/>
           </a:p>
         </p:txBody>
       </p:sp>
@@ -24838,6 +25513,7 @@
           <a:lstStyle/>
           <a:p>
             <a:pPr algn="ctr"/>
+            <a:endParaRPr/>
           </a:p>
         </p:txBody>
       </p:sp>
@@ -24951,6 +25627,7 @@
           <a:lstStyle/>
           <a:p>
             <a:pPr algn="ctr"/>
+            <a:endParaRPr/>
           </a:p>
         </p:txBody>
       </p:sp>
@@ -25067,7 +25744,7 @@
 </file>
 
 <file path=ppt/slides/slide9.xml><?xml version="1.0" encoding="utf-8"?>
-<p:sld xmlns:a="http://schemas.openxmlformats.org/drawingml/2006/main" xmlns:p="http://schemas.openxmlformats.org/presentationml/2006/main" xmlns:r="http://schemas.openxmlformats.org/officeDocument/2006/relationships">
+<p:sld xmlns:a="http://schemas.openxmlformats.org/drawingml/2006/main" xmlns:r="http://schemas.openxmlformats.org/officeDocument/2006/relationships" xmlns:p="http://schemas.openxmlformats.org/presentationml/2006/main">
   <p:cSld>
     <p:spTree>
       <p:nvGrpSpPr>
@@ -25075,7 +25752,14 @@
         <p:cNvGrpSpPr/>
         <p:nvPr/>
       </p:nvGrpSpPr>
-      <p:grpSpPr/>
+      <p:grpSpPr>
+        <a:xfrm>
+          <a:off x="0" y="0"/>
+          <a:ext cx="0" cy="0"/>
+          <a:chOff x="0" y="0"/>
+          <a:chExt cx="0" cy="0"/>
+        </a:xfrm>
+      </p:grpSpPr>
       <p:sp>
         <p:nvSpPr>
           <p:cNvPr id="2" name="Rectangle 1"/>
@@ -25116,6 +25800,7 @@
           <a:lstStyle/>
           <a:p>
             <a:pPr algn="ctr"/>
+            <a:endParaRPr/>
           </a:p>
         </p:txBody>
       </p:sp>
@@ -25159,6 +25844,7 @@
           <a:lstStyle/>
           <a:p>
             <a:pPr algn="ctr"/>
+            <a:endParaRPr/>
           </a:p>
         </p:txBody>
       </p:sp>
@@ -25202,6 +25888,7 @@
           <a:lstStyle/>
           <a:p>
             <a:pPr algn="ctr"/>
+            <a:endParaRPr/>
           </a:p>
         </p:txBody>
       </p:sp>
@@ -25313,6 +26000,7 @@
           <a:lstStyle/>
           <a:p>
             <a:pPr algn="ctr"/>
+            <a:endParaRPr/>
           </a:p>
         </p:txBody>
       </p:sp>
@@ -25340,13 +26028,26 @@
           <a:p>
             <a:pPr algn="l"/>
             <a:r>
-              <a:rPr sz="900" b="0" i="0">
+              <a:rPr sz="900" b="0" i="0" dirty="0">
                 <a:solidFill>
                   <a:srgbClr val="70B5F9"/>
                 </a:solidFill>
               </a:rPr>
-              <a:t>DATA 236 · LinkedIn Platform  |  Group 6</a:t>
-            </a:r>
+              <a:t>DATA 236 · LinkedIn Platform  |  Group </a:t>
+            </a:r>
+            <a:r>
+              <a:rPr lang="en-US" sz="900" b="0" i="0" dirty="0">
+                <a:solidFill>
+                  <a:srgbClr val="70B5F9"/>
+                </a:solidFill>
+              </a:rPr>
+              <a:t>8</a:t>
+            </a:r>
+            <a:endParaRPr sz="900" b="0" i="0" dirty="0">
+              <a:solidFill>
+                <a:srgbClr val="70B5F9"/>
+              </a:solidFill>
+            </a:endParaRPr>
           </a:p>
         </p:txBody>
       </p:sp>
@@ -25424,6 +26125,7 @@
           <a:lstStyle/>
           <a:p>
             <a:pPr algn="ctr"/>
+            <a:endParaRPr/>
           </a:p>
         </p:txBody>
       </p:sp>
@@ -25467,6 +26169,7 @@
           <a:lstStyle/>
           <a:p>
             <a:pPr algn="ctr"/>
+            <a:endParaRPr/>
           </a:p>
         </p:txBody>
       </p:sp>
@@ -25714,6 +26417,7 @@
           <a:lstStyle/>
           <a:p>
             <a:pPr algn="ctr"/>
+            <a:endParaRPr/>
           </a:p>
         </p:txBody>
       </p:sp>
@@ -25757,6 +26461,7 @@
           <a:lstStyle/>
           <a:p>
             <a:pPr algn="ctr"/>
+            <a:endParaRPr/>
           </a:p>
         </p:txBody>
       </p:sp>
@@ -26004,6 +26709,7 @@
           <a:lstStyle/>
           <a:p>
             <a:pPr algn="ctr"/>
+            <a:endParaRPr/>
           </a:p>
         </p:txBody>
       </p:sp>
@@ -26047,6 +26753,7 @@
           <a:lstStyle/>
           <a:p>
             <a:pPr algn="ctr"/>
+            <a:endParaRPr/>
           </a:p>
         </p:txBody>
       </p:sp>
@@ -26294,6 +27001,7 @@
           <a:lstStyle/>
           <a:p>
             <a:pPr algn="ctr"/>
+            <a:endParaRPr/>
           </a:p>
         </p:txBody>
       </p:sp>
@@ -26337,6 +27045,7 @@
           <a:lstStyle/>
           <a:p>
             <a:pPr algn="ctr"/>
+            <a:endParaRPr/>
           </a:p>
         </p:txBody>
       </p:sp>
@@ -26584,6 +27293,7 @@
           <a:lstStyle/>
           <a:p>
             <a:pPr algn="ctr"/>
+            <a:endParaRPr/>
           </a:p>
         </p:txBody>
       </p:sp>
@@ -26627,6 +27337,7 @@
           <a:lstStyle/>
           <a:p>
             <a:pPr algn="ctr"/>
+            <a:endParaRPr/>
           </a:p>
         </p:txBody>
       </p:sp>
@@ -26874,6 +27585,7 @@
           <a:lstStyle/>
           <a:p>
             <a:pPr algn="ctr"/>
+            <a:endParaRPr/>
           </a:p>
         </p:txBody>
       </p:sp>
@@ -26917,6 +27629,7 @@
           <a:lstStyle/>
           <a:p>
             <a:pPr algn="ctr"/>
+            <a:endParaRPr/>
           </a:p>
         </p:txBody>
       </p:sp>
@@ -27164,6 +27877,7 @@
           <a:lstStyle/>
           <a:p>
             <a:pPr algn="ctr"/>
+            <a:endParaRPr/>
           </a:p>
         </p:txBody>
       </p:sp>
@@ -27207,6 +27921,7 @@
           <a:lstStyle/>
           <a:p>
             <a:pPr algn="ctr"/>
+            <a:endParaRPr/>
           </a:p>
         </p:txBody>
       </p:sp>
@@ -27454,6 +28169,7 @@
           <a:lstStyle/>
           <a:p>
             <a:pPr algn="ctr"/>
+            <a:endParaRPr/>
           </a:p>
         </p:txBody>
       </p:sp>
@@ -27497,6 +28213,7 @@
           <a:lstStyle/>
           <a:p>
             <a:pPr algn="ctr"/>
+            <a:endParaRPr/>
           </a:p>
         </p:txBody>
       </p:sp>
@@ -27744,6 +28461,7 @@
           <a:lstStyle/>
           <a:p>
             <a:pPr algn="ctr"/>
+            <a:endParaRPr/>
           </a:p>
         </p:txBody>
       </p:sp>

</xml_diff>